<commit_message>
Fill business case, scope, goal and VOC in Team Charter
Co-Authored-By: Claude Sonnet 5.5 <noreply@anthropic.com>
Claude-Session: https://claude.ai/code/session_01651qhqiTyPfwUXgzopEb4R
</commit_message>
<xml_diff>
--- a/TEAM05_Team_Charter.pptx
+++ b/TEAM05_Team_Charter.pptx
@@ -883,8 +883,8 @@
         </p:nvSpPr>
         <p:spPr>
           <a:xfrm>
-            <a:off x="457200" y="274320"/>
-            <a:ext cx="4754880" cy="640080"/>
+            <a:off x="457200" y="182880"/>
+            <a:ext cx="4206240" cy="502920"/>
           </a:xfrm>
           <a:prstGeom prst="rect">
             <a:avLst/>
@@ -900,7 +900,7 @@
               <a:buNone/>
             </a:pPr>
             <a:r>
-              <a:rPr lang="en-US" sz="3400" dirty="0">
+              <a:rPr lang="en-US" sz="2800" dirty="0">
                 <a:solidFill>
                   <a:srgbClr val="123B3B"/>
                 </a:solidFill>
@@ -910,7 +910,7 @@
               </a:rPr>
               <a:t>TEAM CHARTER</a:t>
             </a:r>
-            <a:endParaRPr lang="en-US" sz="3400" dirty="0"/>
+            <a:endParaRPr lang="en-US" sz="2800" dirty="0"/>
           </a:p>
         </p:txBody>
       </p:sp>
@@ -922,8 +922,8 @@
         </p:nvSpPr>
         <p:spPr>
           <a:xfrm>
-            <a:off x="4572000" y="274320"/>
-            <a:ext cx="4114800" cy="640080"/>
+            <a:off x="4023360" y="182880"/>
+            <a:ext cx="3840480" cy="502920"/>
           </a:xfrm>
           <a:prstGeom prst="rect">
             <a:avLst/>
@@ -939,7 +939,7 @@
               <a:buNone/>
             </a:pPr>
             <a:r>
-              <a:rPr lang="en-US" sz="1800" dirty="0">
+              <a:rPr lang="en-US" sz="1600" dirty="0">
                 <a:solidFill>
                   <a:srgbClr val="123B3B"/>
                 </a:solidFill>
@@ -949,7 +949,7 @@
               </a:rPr>
               <a:t>문제정의 &amp; 프로젝트 합의</a:t>
             </a:r>
-            <a:endParaRPr lang="en-US" sz="1800" dirty="0"/>
+            <a:endParaRPr lang="en-US" sz="1600" dirty="0"/>
           </a:p>
         </p:txBody>
       </p:sp>
@@ -961,8 +961,8 @@
         </p:nvSpPr>
         <p:spPr>
           <a:xfrm>
-            <a:off x="8046720" y="274320"/>
-            <a:ext cx="3685032" cy="274320"/>
+            <a:off x="8046720" y="182880"/>
+            <a:ext cx="3685032" cy="228600"/>
           </a:xfrm>
           <a:prstGeom prst="rect">
             <a:avLst/>
@@ -978,7 +978,7 @@
               <a:buNone/>
             </a:pPr>
             <a:r>
-              <a:rPr lang="en-US" sz="1000" dirty="0">
+              <a:rPr lang="en-US" sz="950" dirty="0">
                 <a:solidFill>
                   <a:srgbClr val="6B6B6B"/>
                 </a:solidFill>
@@ -988,7 +988,7 @@
               </a:rPr>
               <a:t>SeSAC AI 기반 K-뷰티 인재양성 부트캠프</a:t>
             </a:r>
-            <a:endParaRPr lang="en-US" sz="1000" dirty="0"/>
+            <a:endParaRPr lang="en-US" sz="950" dirty="0"/>
           </a:p>
         </p:txBody>
       </p:sp>
@@ -1000,8 +1000,8 @@
         </p:nvSpPr>
         <p:spPr>
           <a:xfrm>
-            <a:off x="8046720" y="566928"/>
-            <a:ext cx="3685032" cy="274320"/>
+            <a:off x="8046720" y="429768"/>
+            <a:ext cx="3685032" cy="228600"/>
           </a:xfrm>
           <a:prstGeom prst="rect">
             <a:avLst/>
@@ -1017,7 +1017,7 @@
               <a:buNone/>
             </a:pPr>
             <a:r>
-              <a:rPr lang="en-US" sz="1000" dirty="0">
+              <a:rPr lang="en-US" sz="950" dirty="0">
                 <a:solidFill>
                   <a:srgbClr val="222222"/>
                 </a:solidFill>
@@ -1027,59 +1027,20 @@
               </a:rPr>
               <a:t>BRANUPCAMPUS · EDUCOS</a:t>
             </a:r>
-            <a:endParaRPr lang="en-US" sz="1000" dirty="0"/>
-          </a:p>
-        </p:txBody>
-      </p:sp>
-      <p:sp>
-        <p:nvSpPr>
-          <p:cNvPr id="6" name="Text 4"/>
-          <p:cNvSpPr txBox="1"/>
-          <p:nvPr/>
-        </p:nvSpPr>
-        <p:spPr>
-          <a:xfrm>
-            <a:off x="457200" y="914400"/>
-            <a:ext cx="8229600" cy="274320"/>
-          </a:xfrm>
-          <a:prstGeom prst="rect">
-            <a:avLst/>
-          </a:prstGeom>
-          <a:noFill/>
-          <a:ln/>
-        </p:spPr>
-        <p:txBody>
-          <a:bodyPr wrap="square" lIns="0" tIns="0" rIns="0" bIns="0" rtlCol="0" anchor="t"/>
-          <a:lstStyle/>
-          <a:p>
-            <a:pPr indent="0" marL="0">
-              <a:buNone/>
-            </a:pPr>
-            <a:r>
-              <a:rPr lang="en-US" sz="1200" dirty="0">
-                <a:solidFill>
-                  <a:srgbClr val="6B6B6B"/>
-                </a:solidFill>
-                <a:latin typeface="Malgun Gothic" pitchFamily="34" charset="0"/>
-                <a:ea typeface="Malgun Gothic" pitchFamily="34" charset="-122"/>
-                <a:cs typeface="Malgun Gothic" pitchFamily="34" charset="-120"/>
-              </a:rPr>
-              <a:t>기업과제를 시작하기 전, 우리 팀이 같은 문제를 보고 있는지 한 장으로 정리합니다.</a:t>
-            </a:r>
-            <a:endParaRPr lang="en-US" sz="1200" dirty="0"/>
-          </a:p>
-        </p:txBody>
-      </p:sp>
-      <p:sp>
-        <p:nvSpPr>
-          <p:cNvPr id="7" name="InfoBar"/>
+            <a:endParaRPr lang="en-US" sz="950" dirty="0"/>
+          </a:p>
+        </p:txBody>
+      </p:sp>
+      <p:sp>
+        <p:nvSpPr>
+          <p:cNvPr id="6" name="InfoBar"/>
           <p:cNvSpPr/>
           <p:nvPr/>
         </p:nvSpPr>
         <p:spPr>
           <a:xfrm>
-            <a:off x="457200" y="1280160"/>
-            <a:ext cx="11274552" cy="502920"/>
+            <a:off x="457200" y="822960"/>
+            <a:ext cx="11274552" cy="411480"/>
           </a:xfrm>
           <a:prstGeom prst="rect">
             <a:avLst/>
@@ -1097,14 +1058,53 @@
       </p:sp>
       <p:sp>
         <p:nvSpPr>
+          <p:cNvPr id="7" name="Text 5"/>
+          <p:cNvSpPr txBox="1"/>
+          <p:nvPr/>
+        </p:nvSpPr>
+        <p:spPr>
+          <a:xfrm>
+            <a:off x="640080" y="822960"/>
+            <a:ext cx="1005840" cy="411480"/>
+          </a:xfrm>
+          <a:prstGeom prst="rect">
+            <a:avLst/>
+          </a:prstGeom>
+          <a:noFill/>
+          <a:ln/>
+        </p:spPr>
+        <p:txBody>
+          <a:bodyPr wrap="square" lIns="0" tIns="0" rIns="0" bIns="0" rtlCol="0" anchor="ctr"/>
+          <a:lstStyle/>
+          <a:p>
+            <a:pPr indent="0" marL="0">
+              <a:buNone/>
+            </a:pPr>
+            <a:r>
+              <a:rPr lang="en-US" sz="1000" dirty="0">
+                <a:solidFill>
+                  <a:srgbClr val="222222"/>
+                </a:solidFill>
+                <a:latin typeface="Malgun Gothic" pitchFamily="34" charset="0"/>
+                <a:ea typeface="Malgun Gothic" pitchFamily="34" charset="-122"/>
+                <a:cs typeface="Malgun Gothic" pitchFamily="34" charset="-120"/>
+              </a:rPr>
+              <a:t>기업 / 브랜드</a:t>
+            </a:r>
+            <a:endParaRPr lang="en-US" sz="1000" dirty="0"/>
+          </a:p>
+        </p:txBody>
+      </p:sp>
+      <p:sp>
+        <p:nvSpPr>
           <p:cNvPr id="8" name="Text 6"/>
           <p:cNvSpPr txBox="1"/>
           <p:nvPr/>
         </p:nvSpPr>
         <p:spPr>
           <a:xfrm>
-            <a:off x="640080" y="1280160"/>
-            <a:ext cx="1005840" cy="502920"/>
+            <a:off x="1600200" y="822960"/>
+            <a:ext cx="2103120" cy="411480"/>
           </a:xfrm>
           <a:prstGeom prst="rect">
             <a:avLst/>
@@ -1120,45 +1120,6 @@
               <a:buNone/>
             </a:pPr>
             <a:r>
-              <a:rPr lang="en-US" sz="1050" dirty="0">
-                <a:solidFill>
-                  <a:srgbClr val="222222"/>
-                </a:solidFill>
-                <a:latin typeface="Malgun Gothic" pitchFamily="34" charset="0"/>
-                <a:ea typeface="Malgun Gothic" pitchFamily="34" charset="-122"/>
-                <a:cs typeface="Malgun Gothic" pitchFamily="34" charset="-120"/>
-              </a:rPr>
-              <a:t>기업 / 브랜드</a:t>
-            </a:r>
-            <a:endParaRPr lang="en-US" sz="1050" dirty="0"/>
-          </a:p>
-        </p:txBody>
-      </p:sp>
-      <p:sp>
-        <p:nvSpPr>
-          <p:cNvPr id="9" name="Text 7"/>
-          <p:cNvSpPr txBox="1"/>
-          <p:nvPr/>
-        </p:nvSpPr>
-        <p:spPr>
-          <a:xfrm>
-            <a:off x="1600200" y="1280160"/>
-            <a:ext cx="2103120" cy="502920"/>
-          </a:xfrm>
-          <a:prstGeom prst="rect">
-            <a:avLst/>
-          </a:prstGeom>
-          <a:noFill/>
-          <a:ln/>
-        </p:spPr>
-        <p:txBody>
-          <a:bodyPr wrap="square" lIns="0" tIns="0" rIns="0" bIns="0" rtlCol="0" anchor="ctr"/>
-          <a:lstStyle/>
-          <a:p>
-            <a:pPr indent="0" marL="0">
-              <a:buNone/>
-            </a:pPr>
-            <a:r>
               <a:rPr lang="en-US" sz="1200" b="1" dirty="0">
                 <a:solidFill>
                   <a:srgbClr val="123B3B"/>
@@ -1175,13 +1136,13 @@
       </p:sp>
       <p:sp>
         <p:nvSpPr>
-          <p:cNvPr id="10" name="Shape 8"/>
+          <p:cNvPr id="9" name="Shape 7"/>
           <p:cNvSpPr/>
           <p:nvPr/>
         </p:nvSpPr>
         <p:spPr>
           <a:xfrm>
-            <a:off x="1600200" y="1664208"/>
+            <a:off x="1600200" y="1161288"/>
             <a:ext cx="2057400" cy="0"/>
           </a:xfrm>
           <a:prstGeom prst="line">
@@ -1198,14 +1159,53 @@
       </p:sp>
       <p:sp>
         <p:nvSpPr>
+          <p:cNvPr id="10" name="Text 8"/>
+          <p:cNvSpPr txBox="1"/>
+          <p:nvPr/>
+        </p:nvSpPr>
+        <p:spPr>
+          <a:xfrm>
+            <a:off x="3931920" y="822960"/>
+            <a:ext cx="1005840" cy="411480"/>
+          </a:xfrm>
+          <a:prstGeom prst="rect">
+            <a:avLst/>
+          </a:prstGeom>
+          <a:noFill/>
+          <a:ln/>
+        </p:spPr>
+        <p:txBody>
+          <a:bodyPr wrap="square" lIns="0" tIns="0" rIns="0" bIns="0" rtlCol="0" anchor="ctr"/>
+          <a:lstStyle/>
+          <a:p>
+            <a:pPr indent="0" marL="0">
+              <a:buNone/>
+            </a:pPr>
+            <a:r>
+              <a:rPr lang="en-US" sz="1000" dirty="0">
+                <a:solidFill>
+                  <a:srgbClr val="222222"/>
+                </a:solidFill>
+                <a:latin typeface="Malgun Gothic" pitchFamily="34" charset="0"/>
+                <a:ea typeface="Malgun Gothic" pitchFamily="34" charset="-122"/>
+                <a:cs typeface="Malgun Gothic" pitchFamily="34" charset="-120"/>
+              </a:rPr>
+              <a:t>팀명</a:t>
+            </a:r>
+            <a:endParaRPr lang="en-US" sz="1000" dirty="0"/>
+          </a:p>
+        </p:txBody>
+      </p:sp>
+      <p:sp>
+        <p:nvSpPr>
           <p:cNvPr id="11" name="Text 9"/>
           <p:cNvSpPr txBox="1"/>
           <p:nvPr/>
         </p:nvSpPr>
         <p:spPr>
           <a:xfrm>
-            <a:off x="3931920" y="1280160"/>
-            <a:ext cx="1005840" cy="502920"/>
+            <a:off x="4892040" y="822960"/>
+            <a:ext cx="1188720" cy="411480"/>
           </a:xfrm>
           <a:prstGeom prst="rect">
             <a:avLst/>
@@ -1221,45 +1221,6 @@
               <a:buNone/>
             </a:pPr>
             <a:r>
-              <a:rPr lang="en-US" sz="1050" dirty="0">
-                <a:solidFill>
-                  <a:srgbClr val="222222"/>
-                </a:solidFill>
-                <a:latin typeface="Malgun Gothic" pitchFamily="34" charset="0"/>
-                <a:ea typeface="Malgun Gothic" pitchFamily="34" charset="-122"/>
-                <a:cs typeface="Malgun Gothic" pitchFamily="34" charset="-120"/>
-              </a:rPr>
-              <a:t>팀명</a:t>
-            </a:r>
-            <a:endParaRPr lang="en-US" sz="1050" dirty="0"/>
-          </a:p>
-        </p:txBody>
-      </p:sp>
-      <p:sp>
-        <p:nvSpPr>
-          <p:cNvPr id="12" name="Text 10"/>
-          <p:cNvSpPr txBox="1"/>
-          <p:nvPr/>
-        </p:nvSpPr>
-        <p:spPr>
-          <a:xfrm>
-            <a:off x="4892040" y="1280160"/>
-            <a:ext cx="1188720" cy="502920"/>
-          </a:xfrm>
-          <a:prstGeom prst="rect">
-            <a:avLst/>
-          </a:prstGeom>
-          <a:noFill/>
-          <a:ln/>
-        </p:spPr>
-        <p:txBody>
-          <a:bodyPr wrap="square" lIns="0" tIns="0" rIns="0" bIns="0" rtlCol="0" anchor="ctr"/>
-          <a:lstStyle/>
-          <a:p>
-            <a:pPr indent="0" marL="0">
-              <a:buNone/>
-            </a:pPr>
-            <a:r>
               <a:rPr lang="en-US" sz="1200" b="1" dirty="0">
                 <a:solidFill>
                   <a:srgbClr val="123B3B"/>
@@ -1276,13 +1237,13 @@
       </p:sp>
       <p:sp>
         <p:nvSpPr>
-          <p:cNvPr id="13" name="Shape 11"/>
+          <p:cNvPr id="12" name="Shape 10"/>
           <p:cNvSpPr/>
           <p:nvPr/>
         </p:nvSpPr>
         <p:spPr>
           <a:xfrm>
-            <a:off x="4892040" y="1664208"/>
+            <a:off x="4892040" y="1161288"/>
             <a:ext cx="1143000" cy="0"/>
           </a:xfrm>
           <a:prstGeom prst="line">
@@ -1299,14 +1260,53 @@
       </p:sp>
       <p:sp>
         <p:nvSpPr>
+          <p:cNvPr id="13" name="Text 11"/>
+          <p:cNvSpPr txBox="1"/>
+          <p:nvPr/>
+        </p:nvSpPr>
+        <p:spPr>
+          <a:xfrm>
+            <a:off x="6309360" y="822960"/>
+            <a:ext cx="1005840" cy="411480"/>
+          </a:xfrm>
+          <a:prstGeom prst="rect">
+            <a:avLst/>
+          </a:prstGeom>
+          <a:noFill/>
+          <a:ln/>
+        </p:spPr>
+        <p:txBody>
+          <a:bodyPr wrap="square" lIns="0" tIns="0" rIns="0" bIns="0" rtlCol="0" anchor="ctr"/>
+          <a:lstStyle/>
+          <a:p>
+            <a:pPr indent="0" marL="0">
+              <a:buNone/>
+            </a:pPr>
+            <a:r>
+              <a:rPr lang="en-US" sz="1000" dirty="0">
+                <a:solidFill>
+                  <a:srgbClr val="222222"/>
+                </a:solidFill>
+                <a:latin typeface="Malgun Gothic" pitchFamily="34" charset="0"/>
+                <a:ea typeface="Malgun Gothic" pitchFamily="34" charset="-122"/>
+                <a:cs typeface="Malgun Gothic" pitchFamily="34" charset="-120"/>
+              </a:rPr>
+              <a:t>과제명</a:t>
+            </a:r>
+            <a:endParaRPr lang="en-US" sz="1000" dirty="0"/>
+          </a:p>
+        </p:txBody>
+      </p:sp>
+      <p:sp>
+        <p:nvSpPr>
           <p:cNvPr id="14" name="Text 12"/>
           <p:cNvSpPr txBox="1"/>
           <p:nvPr/>
         </p:nvSpPr>
         <p:spPr>
           <a:xfrm>
-            <a:off x="6309360" y="1280160"/>
-            <a:ext cx="1005840" cy="502920"/>
+            <a:off x="7269480" y="822960"/>
+            <a:ext cx="2377440" cy="411480"/>
           </a:xfrm>
           <a:prstGeom prst="rect">
             <a:avLst/>
@@ -1321,58 +1321,19 @@
             <a:pPr indent="0" marL="0">
               <a:buNone/>
             </a:pPr>
-            <a:r>
-              <a:rPr lang="en-US" sz="1050" dirty="0">
-                <a:solidFill>
-                  <a:srgbClr val="222222"/>
-                </a:solidFill>
-                <a:latin typeface="Malgun Gothic" pitchFamily="34" charset="0"/>
-                <a:ea typeface="Malgun Gothic" pitchFamily="34" charset="-122"/>
-                <a:cs typeface="Malgun Gothic" pitchFamily="34" charset="-120"/>
-              </a:rPr>
-              <a:t>과제명</a:t>
-            </a:r>
-            <a:endParaRPr lang="en-US" sz="1050" dirty="0"/>
-          </a:p>
-        </p:txBody>
-      </p:sp>
-      <p:sp>
-        <p:nvSpPr>
-          <p:cNvPr id="15" name="Text 13"/>
-          <p:cNvSpPr txBox="1"/>
-          <p:nvPr/>
-        </p:nvSpPr>
-        <p:spPr>
-          <a:xfrm>
-            <a:off x="7269480" y="1280160"/>
-            <a:ext cx="2377440" cy="502920"/>
-          </a:xfrm>
-          <a:prstGeom prst="rect">
-            <a:avLst/>
-          </a:prstGeom>
-          <a:noFill/>
-          <a:ln/>
-        </p:spPr>
-        <p:txBody>
-          <a:bodyPr wrap="square" lIns="0" tIns="0" rIns="0" bIns="0" rtlCol="0" anchor="ctr"/>
-          <a:lstStyle/>
-          <a:p>
-            <a:pPr indent="0" marL="0">
-              <a:buNone/>
-            </a:pPr>
             <a:endParaRPr lang="en-US" sz="1200" dirty="0"/>
           </a:p>
         </p:txBody>
       </p:sp>
       <p:sp>
         <p:nvSpPr>
-          <p:cNvPr id="16" name="Shape 14"/>
+          <p:cNvPr id="15" name="Shape 13"/>
           <p:cNvSpPr/>
           <p:nvPr/>
         </p:nvSpPr>
         <p:spPr>
           <a:xfrm>
-            <a:off x="7269480" y="1664208"/>
+            <a:off x="7269480" y="1161288"/>
             <a:ext cx="2331720" cy="0"/>
           </a:xfrm>
           <a:prstGeom prst="line">
@@ -1389,14 +1350,53 @@
       </p:sp>
       <p:sp>
         <p:nvSpPr>
+          <p:cNvPr id="16" name="Text 14"/>
+          <p:cNvSpPr txBox="1"/>
+          <p:nvPr/>
+        </p:nvSpPr>
+        <p:spPr>
+          <a:xfrm>
+            <a:off x="9875520" y="822960"/>
+            <a:ext cx="1005840" cy="411480"/>
+          </a:xfrm>
+          <a:prstGeom prst="rect">
+            <a:avLst/>
+          </a:prstGeom>
+          <a:noFill/>
+          <a:ln/>
+        </p:spPr>
+        <p:txBody>
+          <a:bodyPr wrap="square" lIns="0" tIns="0" rIns="0" bIns="0" rtlCol="0" anchor="ctr"/>
+          <a:lstStyle/>
+          <a:p>
+            <a:pPr indent="0" marL="0">
+              <a:buNone/>
+            </a:pPr>
+            <a:r>
+              <a:rPr lang="en-US" sz="1000" dirty="0">
+                <a:solidFill>
+                  <a:srgbClr val="222222"/>
+                </a:solidFill>
+                <a:latin typeface="Malgun Gothic" pitchFamily="34" charset="0"/>
+                <a:ea typeface="Malgun Gothic" pitchFamily="34" charset="-122"/>
+                <a:cs typeface="Malgun Gothic" pitchFamily="34" charset="-120"/>
+              </a:rPr>
+              <a:t>작성일</a:t>
+            </a:r>
+            <a:endParaRPr lang="en-US" sz="1000" dirty="0"/>
+          </a:p>
+        </p:txBody>
+      </p:sp>
+      <p:sp>
+        <p:nvSpPr>
           <p:cNvPr id="17" name="Text 15"/>
           <p:cNvSpPr txBox="1"/>
           <p:nvPr/>
         </p:nvSpPr>
         <p:spPr>
           <a:xfrm>
-            <a:off x="9875520" y="1280160"/>
-            <a:ext cx="1005840" cy="502920"/>
+            <a:off x="10835640" y="822960"/>
+            <a:ext cx="822960" cy="411480"/>
           </a:xfrm>
           <a:prstGeom prst="rect">
             <a:avLst/>
@@ -1411,58 +1411,19 @@
             <a:pPr indent="0" marL="0">
               <a:buNone/>
             </a:pPr>
-            <a:r>
-              <a:rPr lang="en-US" sz="1050" dirty="0">
-                <a:solidFill>
-                  <a:srgbClr val="222222"/>
-                </a:solidFill>
-                <a:latin typeface="Malgun Gothic" pitchFamily="34" charset="0"/>
-                <a:ea typeface="Malgun Gothic" pitchFamily="34" charset="-122"/>
-                <a:cs typeface="Malgun Gothic" pitchFamily="34" charset="-120"/>
-              </a:rPr>
-              <a:t>작성일</a:t>
-            </a:r>
-            <a:endParaRPr lang="en-US" sz="1050" dirty="0"/>
-          </a:p>
-        </p:txBody>
-      </p:sp>
-      <p:sp>
-        <p:nvSpPr>
-          <p:cNvPr id="18" name="Text 16"/>
-          <p:cNvSpPr txBox="1"/>
-          <p:nvPr/>
-        </p:nvSpPr>
-        <p:spPr>
-          <a:xfrm>
-            <a:off x="10835640" y="1280160"/>
-            <a:ext cx="822960" cy="502920"/>
-          </a:xfrm>
-          <a:prstGeom prst="rect">
-            <a:avLst/>
-          </a:prstGeom>
-          <a:noFill/>
-          <a:ln/>
-        </p:spPr>
-        <p:txBody>
-          <a:bodyPr wrap="square" lIns="0" tIns="0" rIns="0" bIns="0" rtlCol="0" anchor="ctr"/>
-          <a:lstStyle/>
-          <a:p>
-            <a:pPr indent="0" marL="0">
-              <a:buNone/>
-            </a:pPr>
             <a:endParaRPr lang="en-US" sz="1200" dirty="0"/>
           </a:p>
         </p:txBody>
       </p:sp>
       <p:sp>
         <p:nvSpPr>
-          <p:cNvPr id="19" name="Shape 17"/>
+          <p:cNvPr id="18" name="Shape 16"/>
           <p:cNvSpPr/>
           <p:nvPr/>
         </p:nvSpPr>
         <p:spPr>
           <a:xfrm>
-            <a:off x="10835640" y="1664208"/>
+            <a:off x="10835640" y="1161288"/>
             <a:ext cx="777240" cy="0"/>
           </a:xfrm>
           <a:prstGeom prst="line">
@@ -1479,14 +1440,14 @@
       </p:sp>
       <p:sp>
         <p:nvSpPr>
-          <p:cNvPr id="20" name="Card01"/>
+          <p:cNvPr id="19" name="Card01"/>
           <p:cNvSpPr/>
           <p:nvPr/>
         </p:nvSpPr>
         <p:spPr>
           <a:xfrm>
-            <a:off x="457200" y="1965960"/>
-            <a:ext cx="3108960" cy="1371600"/>
+            <a:off x="457200" y="1371600"/>
+            <a:ext cx="5943600" cy="2560320"/>
           </a:xfrm>
           <a:prstGeom prst="rect">
             <a:avLst/>
@@ -1504,14 +1465,14 @@
       </p:sp>
       <p:sp>
         <p:nvSpPr>
-          <p:cNvPr id="21" name="Card01Header"/>
+          <p:cNvPr id="20" name="Card01Header"/>
           <p:cNvSpPr/>
           <p:nvPr/>
         </p:nvSpPr>
         <p:spPr>
           <a:xfrm>
-            <a:off x="457200" y="1965960"/>
-            <a:ext cx="3108960" cy="384048"/>
+            <a:off x="457200" y="1371600"/>
+            <a:ext cx="5943600" cy="329184"/>
           </a:xfrm>
           <a:prstGeom prst="rect">
             <a:avLst/>
@@ -1529,14 +1490,53 @@
       </p:sp>
       <p:sp>
         <p:nvSpPr>
+          <p:cNvPr id="21" name="Text 19"/>
+          <p:cNvSpPr txBox="1"/>
+          <p:nvPr/>
+        </p:nvSpPr>
+        <p:spPr>
+          <a:xfrm>
+            <a:off x="566928" y="1371600"/>
+            <a:ext cx="320040" cy="329184"/>
+          </a:xfrm>
+          <a:prstGeom prst="rect">
+            <a:avLst/>
+          </a:prstGeom>
+          <a:noFill/>
+          <a:ln/>
+        </p:spPr>
+        <p:txBody>
+          <a:bodyPr wrap="square" lIns="0" tIns="0" rIns="0" bIns="0" rtlCol="0" anchor="ctr"/>
+          <a:lstStyle/>
+          <a:p>
+            <a:pPr indent="0" marL="0">
+              <a:buNone/>
+            </a:pPr>
+            <a:r>
+              <a:rPr lang="en-US" sz="1050" dirty="0">
+                <a:solidFill>
+                  <a:srgbClr val="1B8A7A"/>
+                </a:solidFill>
+                <a:latin typeface="Malgun Gothic" pitchFamily="34" charset="0"/>
+                <a:ea typeface="Malgun Gothic" pitchFamily="34" charset="-122"/>
+                <a:cs typeface="Malgun Gothic" pitchFamily="34" charset="-120"/>
+              </a:rPr>
+              <a:t>01</a:t>
+            </a:r>
+            <a:endParaRPr lang="en-US" sz="1050" dirty="0"/>
+          </a:p>
+        </p:txBody>
+      </p:sp>
+      <p:sp>
+        <p:nvSpPr>
           <p:cNvPr id="22" name="Text 20"/>
           <p:cNvSpPr txBox="1"/>
           <p:nvPr/>
         </p:nvSpPr>
         <p:spPr>
           <a:xfrm>
-            <a:off x="594360" y="1965960"/>
-            <a:ext cx="365760" cy="384048"/>
+            <a:off x="914400" y="1371600"/>
+            <a:ext cx="4434840" cy="329184"/>
           </a:xfrm>
           <a:prstGeom prst="rect">
             <a:avLst/>
@@ -1552,17 +1552,17 @@
               <a:buNone/>
             </a:pPr>
             <a:r>
-              <a:rPr lang="en-US" sz="1100" dirty="0">
-                <a:solidFill>
-                  <a:srgbClr val="1B8A7A"/>
-                </a:solidFill>
-                <a:latin typeface="Malgun Gothic" pitchFamily="34" charset="0"/>
-                <a:ea typeface="Malgun Gothic" pitchFamily="34" charset="-122"/>
-                <a:cs typeface="Malgun Gothic" pitchFamily="34" charset="-120"/>
-              </a:rPr>
-              <a:t>01</a:t>
-            </a:r>
-            <a:endParaRPr lang="en-US" sz="1100" dirty="0"/>
+              <a:rPr lang="en-US" sz="1250" b="1" dirty="0">
+                <a:solidFill>
+                  <a:srgbClr val="123B3B"/>
+                </a:solidFill>
+                <a:latin typeface="Malgun Gothic" pitchFamily="34" charset="0"/>
+                <a:ea typeface="Malgun Gothic" pitchFamily="34" charset="-122"/>
+                <a:cs typeface="Malgun Gothic" pitchFamily="34" charset="-120"/>
+              </a:rPr>
+              <a:t>비즈니스 케이스</a:t>
+            </a:r>
+            <a:endParaRPr lang="en-US" sz="1250" dirty="0"/>
           </a:p>
         </p:txBody>
       </p:sp>
@@ -1574,8 +1574,8 @@
         </p:nvSpPr>
         <p:spPr>
           <a:xfrm>
-            <a:off x="960120" y="1965960"/>
-            <a:ext cx="1508760" cy="384048"/>
+            <a:off x="5303520" y="1371600"/>
+            <a:ext cx="1005840" cy="329184"/>
           </a:xfrm>
           <a:prstGeom prst="rect">
             <a:avLst/>
@@ -1587,50 +1587,11 @@
           <a:bodyPr wrap="square" lIns="0" tIns="0" rIns="0" bIns="0" rtlCol="0" anchor="ctr"/>
           <a:lstStyle/>
           <a:p>
-            <a:pPr indent="0" marL="0">
-              <a:buNone/>
-            </a:pPr>
-            <a:r>
-              <a:rPr lang="en-US" sz="1300" b="1" dirty="0">
-                <a:solidFill>
-                  <a:srgbClr val="123B3B"/>
-                </a:solidFill>
-                <a:latin typeface="Malgun Gothic" pitchFamily="34" charset="0"/>
-                <a:ea typeface="Malgun Gothic" pitchFamily="34" charset="-122"/>
-                <a:cs typeface="Malgun Gothic" pitchFamily="34" charset="-120"/>
-              </a:rPr>
-              <a:t>비즈니스 케이스</a:t>
-            </a:r>
-            <a:endParaRPr lang="en-US" sz="1300" dirty="0"/>
-          </a:p>
-        </p:txBody>
-      </p:sp>
-      <p:sp>
-        <p:nvSpPr>
-          <p:cNvPr id="24" name="Text 22"/>
-          <p:cNvSpPr txBox="1"/>
-          <p:nvPr/>
-        </p:nvSpPr>
-        <p:spPr>
-          <a:xfrm>
-            <a:off x="2240280" y="1965960"/>
-            <a:ext cx="1188720" cy="384048"/>
-          </a:xfrm>
-          <a:prstGeom prst="rect">
-            <a:avLst/>
-          </a:prstGeom>
-          <a:noFill/>
-          <a:ln/>
-        </p:spPr>
-        <p:txBody>
-          <a:bodyPr wrap="square" lIns="0" tIns="0" rIns="0" bIns="0" rtlCol="0" anchor="ctr"/>
-          <a:lstStyle/>
-          <a:p>
             <a:pPr algn="r" indent="0" marL="0">
               <a:buNone/>
             </a:pPr>
             <a:r>
-              <a:rPr lang="en-US" sz="850" dirty="0">
+              <a:rPr lang="en-US" sz="750" dirty="0">
                 <a:solidFill>
                   <a:srgbClr val="6B6B6B"/>
                 </a:solidFill>
@@ -1640,59 +1601,20 @@
               </a:rPr>
               <a:t>BUSINESS CASE</a:t>
             </a:r>
-            <a:endParaRPr lang="en-US" sz="850" dirty="0"/>
-          </a:p>
-        </p:txBody>
-      </p:sp>
-      <p:sp>
-        <p:nvSpPr>
-          <p:cNvPr id="25" name="Card01Body"/>
-          <p:cNvSpPr txBox="1"/>
-          <p:nvPr/>
-        </p:nvSpPr>
-        <p:spPr>
-          <a:xfrm>
-            <a:off x="621792" y="2441448"/>
-            <a:ext cx="2779776" cy="804672"/>
-          </a:xfrm>
-          <a:prstGeom prst="rect">
-            <a:avLst/>
-          </a:prstGeom>
-          <a:noFill/>
-          <a:ln/>
-        </p:spPr>
-        <p:txBody>
-          <a:bodyPr wrap="square" lIns="0" tIns="0" rIns="0" bIns="0" rtlCol="0" anchor="t"/>
-          <a:lstStyle/>
-          <a:p>
-            <a:pPr indent="0" marL="0">
-              <a:buNone/>
-            </a:pPr>
-            <a:r>
-              <a:rPr lang="en-US" sz="1050" dirty="0">
-                <a:solidFill>
-                  <a:srgbClr val="6B6B6B"/>
-                </a:solidFill>
-                <a:latin typeface="Malgun Gothic" pitchFamily="34" charset="0"/>
-                <a:ea typeface="Malgun Gothic" pitchFamily="34" charset="-122"/>
-                <a:cs typeface="Malgun Gothic" pitchFamily="34" charset="-120"/>
-              </a:rPr>
-              <a:t>왜 이 과제를 해야 하는가? 기업·고객·시장 관점에서 해결 필요성과 기대 가치를 자유롭게 적습니다.</a:t>
-            </a:r>
-            <a:endParaRPr lang="en-US" sz="1050" dirty="0"/>
-          </a:p>
-        </p:txBody>
-      </p:sp>
-      <p:sp>
-        <p:nvSpPr>
-          <p:cNvPr id="26" name="Card02"/>
+            <a:endParaRPr lang="en-US" sz="750" dirty="0"/>
+          </a:p>
+        </p:txBody>
+      </p:sp>
+      <p:sp>
+        <p:nvSpPr>
+          <p:cNvPr id="24" name="Card02"/>
           <p:cNvSpPr/>
           <p:nvPr/>
         </p:nvSpPr>
         <p:spPr>
           <a:xfrm>
-            <a:off x="3749040" y="1965960"/>
-            <a:ext cx="3383280" cy="1371600"/>
+            <a:off x="6583680" y="1371600"/>
+            <a:ext cx="2743200" cy="2560320"/>
           </a:xfrm>
           <a:prstGeom prst="rect">
             <a:avLst/>
@@ -1710,14 +1632,14 @@
       </p:sp>
       <p:sp>
         <p:nvSpPr>
-          <p:cNvPr id="27" name="Card02Header"/>
+          <p:cNvPr id="25" name="Card02Header"/>
           <p:cNvSpPr/>
           <p:nvPr/>
         </p:nvSpPr>
         <p:spPr>
           <a:xfrm>
-            <a:off x="3749040" y="1965960"/>
-            <a:ext cx="3383280" cy="384048"/>
+            <a:off x="6583680" y="1371600"/>
+            <a:ext cx="2743200" cy="329184"/>
           </a:xfrm>
           <a:prstGeom prst="rect">
             <a:avLst/>
@@ -1735,14 +1657,92 @@
       </p:sp>
       <p:sp>
         <p:nvSpPr>
+          <p:cNvPr id="26" name="Text 24"/>
+          <p:cNvSpPr txBox="1"/>
+          <p:nvPr/>
+        </p:nvSpPr>
+        <p:spPr>
+          <a:xfrm>
+            <a:off x="6693408" y="1371600"/>
+            <a:ext cx="320040" cy="329184"/>
+          </a:xfrm>
+          <a:prstGeom prst="rect">
+            <a:avLst/>
+          </a:prstGeom>
+          <a:noFill/>
+          <a:ln/>
+        </p:spPr>
+        <p:txBody>
+          <a:bodyPr wrap="square" lIns="0" tIns="0" rIns="0" bIns="0" rtlCol="0" anchor="ctr"/>
+          <a:lstStyle/>
+          <a:p>
+            <a:pPr indent="0" marL="0">
+              <a:buNone/>
+            </a:pPr>
+            <a:r>
+              <a:rPr lang="en-US" sz="1050" dirty="0">
+                <a:solidFill>
+                  <a:srgbClr val="1B8A7A"/>
+                </a:solidFill>
+                <a:latin typeface="Malgun Gothic" pitchFamily="34" charset="0"/>
+                <a:ea typeface="Malgun Gothic" pitchFamily="34" charset="-122"/>
+                <a:cs typeface="Malgun Gothic" pitchFamily="34" charset="-120"/>
+              </a:rPr>
+              <a:t>02</a:t>
+            </a:r>
+            <a:endParaRPr lang="en-US" sz="1050" dirty="0"/>
+          </a:p>
+        </p:txBody>
+      </p:sp>
+      <p:sp>
+        <p:nvSpPr>
+          <p:cNvPr id="27" name="Text 25"/>
+          <p:cNvSpPr txBox="1"/>
+          <p:nvPr/>
+        </p:nvSpPr>
+        <p:spPr>
+          <a:xfrm>
+            <a:off x="7040880" y="1371600"/>
+            <a:ext cx="1234440" cy="329184"/>
+          </a:xfrm>
+          <a:prstGeom prst="rect">
+            <a:avLst/>
+          </a:prstGeom>
+          <a:noFill/>
+          <a:ln/>
+        </p:spPr>
+        <p:txBody>
+          <a:bodyPr wrap="square" lIns="0" tIns="0" rIns="0" bIns="0" rtlCol="0" anchor="ctr"/>
+          <a:lstStyle/>
+          <a:p>
+            <a:pPr indent="0" marL="0">
+              <a:buNone/>
+            </a:pPr>
+            <a:r>
+              <a:rPr lang="en-US" sz="1250" b="1" dirty="0">
+                <a:solidFill>
+                  <a:srgbClr val="123B3B"/>
+                </a:solidFill>
+                <a:latin typeface="Malgun Gothic" pitchFamily="34" charset="0"/>
+                <a:ea typeface="Malgun Gothic" pitchFamily="34" charset="-122"/>
+                <a:cs typeface="Malgun Gothic" pitchFamily="34" charset="-120"/>
+              </a:rPr>
+              <a:t>과제 범위</a:t>
+            </a:r>
+            <a:endParaRPr lang="en-US" sz="1250" dirty="0"/>
+          </a:p>
+        </p:txBody>
+      </p:sp>
+      <p:sp>
+        <p:nvSpPr>
           <p:cNvPr id="28" name="Text 26"/>
           <p:cNvSpPr txBox="1"/>
           <p:nvPr/>
         </p:nvSpPr>
         <p:spPr>
           <a:xfrm>
-            <a:off x="3886200" y="1965960"/>
-            <a:ext cx="365760" cy="384048"/>
+            <a:off x="8229600" y="1371600"/>
+            <a:ext cx="1005840" cy="329184"/>
           </a:xfrm>
           <a:prstGeom prst="rect">
             <a:avLst/>
@@ -1754,89 +1754,11 @@
           <a:bodyPr wrap="square" lIns="0" tIns="0" rIns="0" bIns="0" rtlCol="0" anchor="ctr"/>
           <a:lstStyle/>
           <a:p>
-            <a:pPr indent="0" marL="0">
-              <a:buNone/>
-            </a:pPr>
-            <a:r>
-              <a:rPr lang="en-US" sz="1100" dirty="0">
-                <a:solidFill>
-                  <a:srgbClr val="1B8A7A"/>
-                </a:solidFill>
-                <a:latin typeface="Malgun Gothic" pitchFamily="34" charset="0"/>
-                <a:ea typeface="Malgun Gothic" pitchFamily="34" charset="-122"/>
-                <a:cs typeface="Malgun Gothic" pitchFamily="34" charset="-120"/>
-              </a:rPr>
-              <a:t>02</a:t>
-            </a:r>
-            <a:endParaRPr lang="en-US" sz="1100" dirty="0"/>
-          </a:p>
-        </p:txBody>
-      </p:sp>
-      <p:sp>
-        <p:nvSpPr>
-          <p:cNvPr id="29" name="Text 27"/>
-          <p:cNvSpPr txBox="1"/>
-          <p:nvPr/>
-        </p:nvSpPr>
-        <p:spPr>
-          <a:xfrm>
-            <a:off x="4251960" y="1965960"/>
-            <a:ext cx="1783080" cy="384048"/>
-          </a:xfrm>
-          <a:prstGeom prst="rect">
-            <a:avLst/>
-          </a:prstGeom>
-          <a:noFill/>
-          <a:ln/>
-        </p:spPr>
-        <p:txBody>
-          <a:bodyPr wrap="square" lIns="0" tIns="0" rIns="0" bIns="0" rtlCol="0" anchor="ctr"/>
-          <a:lstStyle/>
-          <a:p>
-            <a:pPr indent="0" marL="0">
-              <a:buNone/>
-            </a:pPr>
-            <a:r>
-              <a:rPr lang="en-US" sz="1300" b="1" dirty="0">
-                <a:solidFill>
-                  <a:srgbClr val="123B3B"/>
-                </a:solidFill>
-                <a:latin typeface="Malgun Gothic" pitchFamily="34" charset="0"/>
-                <a:ea typeface="Malgun Gothic" pitchFamily="34" charset="-122"/>
-                <a:cs typeface="Malgun Gothic" pitchFamily="34" charset="-120"/>
-              </a:rPr>
-              <a:t>과제 범위</a:t>
-            </a:r>
-            <a:endParaRPr lang="en-US" sz="1300" dirty="0"/>
-          </a:p>
-        </p:txBody>
-      </p:sp>
-      <p:sp>
-        <p:nvSpPr>
-          <p:cNvPr id="30" name="Text 28"/>
-          <p:cNvSpPr txBox="1"/>
-          <p:nvPr/>
-        </p:nvSpPr>
-        <p:spPr>
-          <a:xfrm>
-            <a:off x="5806440" y="1965960"/>
-            <a:ext cx="1188720" cy="384048"/>
-          </a:xfrm>
-          <a:prstGeom prst="rect">
-            <a:avLst/>
-          </a:prstGeom>
-          <a:noFill/>
-          <a:ln/>
-        </p:spPr>
-        <p:txBody>
-          <a:bodyPr wrap="square" lIns="0" tIns="0" rIns="0" bIns="0" rtlCol="0" anchor="ctr"/>
-          <a:lstStyle/>
-          <a:p>
             <a:pPr algn="r" indent="0" marL="0">
               <a:buNone/>
             </a:pPr>
             <a:r>
-              <a:rPr lang="en-US" sz="850" dirty="0">
+              <a:rPr lang="en-US" sz="750" dirty="0">
                 <a:solidFill>
                   <a:srgbClr val="6B6B6B"/>
                 </a:solidFill>
@@ -1846,59 +1768,20 @@
               </a:rPr>
               <a:t>PROJECT SCOPE</a:t>
             </a:r>
-            <a:endParaRPr lang="en-US" sz="850" dirty="0"/>
-          </a:p>
-        </p:txBody>
-      </p:sp>
-      <p:sp>
-        <p:nvSpPr>
-          <p:cNvPr id="31" name="Card02Body"/>
-          <p:cNvSpPr txBox="1"/>
-          <p:nvPr/>
-        </p:nvSpPr>
-        <p:spPr>
-          <a:xfrm>
-            <a:off x="3913632" y="2441448"/>
-            <a:ext cx="3054096" cy="804672"/>
-          </a:xfrm>
-          <a:prstGeom prst="rect">
-            <a:avLst/>
-          </a:prstGeom>
-          <a:noFill/>
-          <a:ln/>
-        </p:spPr>
-        <p:txBody>
-          <a:bodyPr wrap="square" lIns="0" tIns="0" rIns="0" bIns="0" rtlCol="0" anchor="t"/>
-          <a:lstStyle/>
-          <a:p>
-            <a:pPr indent="0" marL="0">
-              <a:buNone/>
-            </a:pPr>
-            <a:r>
-              <a:rPr lang="en-US" sz="1050" dirty="0">
-                <a:solidFill>
-                  <a:srgbClr val="6B6B6B"/>
-                </a:solidFill>
-                <a:latin typeface="Malgun Gothic" pitchFamily="34" charset="0"/>
-                <a:ea typeface="Malgun Gothic" pitchFamily="34" charset="-122"/>
-                <a:cs typeface="Malgun Gothic" pitchFamily="34" charset="-120"/>
-              </a:rPr>
-              <a:t>이번 프로젝트에서 다룰 대상과 경계를 정합니다. 제품·고객·채널·시장 등 포함 / 제외 범위를 간단히 적습니다.</a:t>
-            </a:r>
-            <a:endParaRPr lang="en-US" sz="1050" dirty="0"/>
-          </a:p>
-        </p:txBody>
-      </p:sp>
-      <p:sp>
-        <p:nvSpPr>
-          <p:cNvPr id="32" name="Card03"/>
+            <a:endParaRPr lang="en-US" sz="750" dirty="0"/>
+          </a:p>
+        </p:txBody>
+      </p:sp>
+      <p:sp>
+        <p:nvSpPr>
+          <p:cNvPr id="29" name="Card03"/>
           <p:cNvSpPr/>
           <p:nvPr/>
         </p:nvSpPr>
         <p:spPr>
           <a:xfrm>
-            <a:off x="7315200" y="1965960"/>
-            <a:ext cx="4416552" cy="1371600"/>
+            <a:off x="9509760" y="1371600"/>
+            <a:ext cx="2221992" cy="2560320"/>
           </a:xfrm>
           <a:prstGeom prst="rect">
             <a:avLst/>
@@ -1916,14 +1799,14 @@
       </p:sp>
       <p:sp>
         <p:nvSpPr>
-          <p:cNvPr id="33" name="Card03Header"/>
+          <p:cNvPr id="30" name="Card03Header"/>
           <p:cNvSpPr/>
           <p:nvPr/>
         </p:nvSpPr>
         <p:spPr>
           <a:xfrm>
-            <a:off x="7315200" y="1965960"/>
-            <a:ext cx="4416552" cy="384048"/>
+            <a:off x="9509760" y="1371600"/>
+            <a:ext cx="2221992" cy="329184"/>
           </a:xfrm>
           <a:prstGeom prst="rect">
             <a:avLst/>
@@ -1941,14 +1824,14 @@
       </p:sp>
       <p:sp>
         <p:nvSpPr>
-          <p:cNvPr id="34" name="Text 32"/>
+          <p:cNvPr id="31" name="Text 29"/>
           <p:cNvSpPr txBox="1"/>
           <p:nvPr/>
         </p:nvSpPr>
         <p:spPr>
           <a:xfrm>
-            <a:off x="7452360" y="1965960"/>
-            <a:ext cx="365760" cy="384048"/>
+            <a:off x="9619488" y="1371600"/>
+            <a:ext cx="320040" cy="329184"/>
           </a:xfrm>
           <a:prstGeom prst="rect">
             <a:avLst/>
@@ -1964,7 +1847,7 @@
               <a:buNone/>
             </a:pPr>
             <a:r>
-              <a:rPr lang="en-US" sz="1100" dirty="0">
+              <a:rPr lang="en-US" sz="1050" dirty="0">
                 <a:solidFill>
                   <a:srgbClr val="1B8A7A"/>
                 </a:solidFill>
@@ -1974,20 +1857,20 @@
               </a:rPr>
               <a:t>03</a:t>
             </a:r>
-            <a:endParaRPr lang="en-US" sz="1100" dirty="0"/>
-          </a:p>
-        </p:txBody>
-      </p:sp>
-      <p:sp>
-        <p:nvSpPr>
-          <p:cNvPr id="35" name="Text 33"/>
+            <a:endParaRPr lang="en-US" sz="1050" dirty="0"/>
+          </a:p>
+        </p:txBody>
+      </p:sp>
+      <p:sp>
+        <p:nvSpPr>
+          <p:cNvPr id="32" name="Text 30"/>
           <p:cNvSpPr txBox="1"/>
           <p:nvPr/>
         </p:nvSpPr>
         <p:spPr>
           <a:xfrm>
-            <a:off x="7818120" y="1965960"/>
-            <a:ext cx="2816352" cy="384048"/>
+            <a:off x="9966960" y="1371600"/>
+            <a:ext cx="713232" cy="329184"/>
           </a:xfrm>
           <a:prstGeom prst="rect">
             <a:avLst/>
@@ -2003,7 +1886,7 @@
               <a:buNone/>
             </a:pPr>
             <a:r>
-              <a:rPr lang="en-US" sz="1300" b="1" dirty="0">
+              <a:rPr lang="en-US" sz="1250" b="1" dirty="0">
                 <a:solidFill>
                   <a:srgbClr val="123B3B"/>
                 </a:solidFill>
@@ -2013,20 +1896,20 @@
               </a:rPr>
               <a:t>과제 목표</a:t>
             </a:r>
-            <a:endParaRPr lang="en-US" sz="1300" dirty="0"/>
-          </a:p>
-        </p:txBody>
-      </p:sp>
-      <p:sp>
-        <p:nvSpPr>
-          <p:cNvPr id="36" name="Text 34"/>
+            <a:endParaRPr lang="en-US" sz="1250" dirty="0"/>
+          </a:p>
+        </p:txBody>
+      </p:sp>
+      <p:sp>
+        <p:nvSpPr>
+          <p:cNvPr id="33" name="Text 31"/>
           <p:cNvSpPr txBox="1"/>
           <p:nvPr/>
         </p:nvSpPr>
         <p:spPr>
           <a:xfrm>
-            <a:off x="10405872" y="1965960"/>
-            <a:ext cx="1188720" cy="384048"/>
+            <a:off x="10634472" y="1371600"/>
+            <a:ext cx="1005840" cy="329184"/>
           </a:xfrm>
           <a:prstGeom prst="rect">
             <a:avLst/>
@@ -2042,7 +1925,7 @@
               <a:buNone/>
             </a:pPr>
             <a:r>
-              <a:rPr lang="en-US" sz="850" dirty="0">
+              <a:rPr lang="en-US" sz="750" dirty="0">
                 <a:solidFill>
                   <a:srgbClr val="6B6B6B"/>
                 </a:solidFill>
@@ -2052,59 +1935,20 @@
               </a:rPr>
               <a:t>PROJECT GOAL</a:t>
             </a:r>
-            <a:endParaRPr lang="en-US" sz="850" dirty="0"/>
-          </a:p>
-        </p:txBody>
-      </p:sp>
-      <p:sp>
-        <p:nvSpPr>
-          <p:cNvPr id="37" name="Card03Body"/>
-          <p:cNvSpPr txBox="1"/>
-          <p:nvPr/>
-        </p:nvSpPr>
-        <p:spPr>
-          <a:xfrm>
-            <a:off x="7479792" y="2441448"/>
-            <a:ext cx="4087368" cy="804672"/>
-          </a:xfrm>
-          <a:prstGeom prst="rect">
-            <a:avLst/>
-          </a:prstGeom>
-          <a:noFill/>
-          <a:ln/>
-        </p:spPr>
-        <p:txBody>
-          <a:bodyPr wrap="square" lIns="0" tIns="0" rIns="0" bIns="0" rtlCol="0" anchor="t"/>
-          <a:lstStyle/>
-          <a:p>
-            <a:pPr indent="0" marL="0">
-              <a:buNone/>
-            </a:pPr>
-            <a:r>
-              <a:rPr lang="en-US" sz="1050" dirty="0">
-                <a:solidFill>
-                  <a:srgbClr val="6B6B6B"/>
-                </a:solidFill>
-                <a:latin typeface="Malgun Gothic" pitchFamily="34" charset="0"/>
-                <a:ea typeface="Malgun Gothic" pitchFamily="34" charset="-122"/>
-                <a:cs typeface="Malgun Gothic" pitchFamily="34" charset="-120"/>
-              </a:rPr>
-              <a:t>프로젝트가 끝났을 때 무엇이 달라져 있어야 하는가? 팀이 만들고 싶은 변화 또는 완료 기준을 적습니다.</a:t>
-            </a:r>
-            <a:endParaRPr lang="en-US" sz="1050" dirty="0"/>
-          </a:p>
-        </p:txBody>
-      </p:sp>
-      <p:sp>
-        <p:nvSpPr>
-          <p:cNvPr id="38" name="Card04"/>
+            <a:endParaRPr lang="en-US" sz="750" dirty="0"/>
+          </a:p>
+        </p:txBody>
+      </p:sp>
+      <p:sp>
+        <p:nvSpPr>
+          <p:cNvPr id="34" name="Card04"/>
           <p:cNvSpPr/>
           <p:nvPr/>
         </p:nvSpPr>
         <p:spPr>
           <a:xfrm>
-            <a:off x="457200" y="3520440"/>
-            <a:ext cx="3108960" cy="2880360"/>
+            <a:off x="457200" y="4069080"/>
+            <a:ext cx="3337560" cy="2377440"/>
           </a:xfrm>
           <a:prstGeom prst="rect">
             <a:avLst/>
@@ -2122,14 +1966,14 @@
       </p:sp>
       <p:sp>
         <p:nvSpPr>
-          <p:cNvPr id="39" name="Card04Header"/>
+          <p:cNvPr id="35" name="Card04Header"/>
           <p:cNvSpPr/>
           <p:nvPr/>
         </p:nvSpPr>
         <p:spPr>
           <a:xfrm>
-            <a:off x="457200" y="3520440"/>
-            <a:ext cx="3108960" cy="384048"/>
+            <a:off x="457200" y="4069080"/>
+            <a:ext cx="3337560" cy="329184"/>
           </a:xfrm>
           <a:prstGeom prst="rect">
             <a:avLst/>
@@ -2147,14 +1991,14 @@
       </p:sp>
       <p:sp>
         <p:nvSpPr>
-          <p:cNvPr id="40" name="Text 38"/>
+          <p:cNvPr id="36" name="Text 34"/>
           <p:cNvSpPr txBox="1"/>
           <p:nvPr/>
         </p:nvSpPr>
         <p:spPr>
           <a:xfrm>
-            <a:off x="594360" y="3520440"/>
-            <a:ext cx="365760" cy="384048"/>
+            <a:off x="566928" y="4069080"/>
+            <a:ext cx="320040" cy="329184"/>
           </a:xfrm>
           <a:prstGeom prst="rect">
             <a:avLst/>
@@ -2170,7 +2014,7 @@
               <a:buNone/>
             </a:pPr>
             <a:r>
-              <a:rPr lang="en-US" sz="1100" dirty="0">
+              <a:rPr lang="en-US" sz="1050" dirty="0">
                 <a:solidFill>
                   <a:srgbClr val="1B8A7A"/>
                 </a:solidFill>
@@ -2180,20 +2024,20 @@
               </a:rPr>
               <a:t>04</a:t>
             </a:r>
-            <a:endParaRPr lang="en-US" sz="1100" dirty="0"/>
-          </a:p>
-        </p:txBody>
-      </p:sp>
-      <p:sp>
-        <p:nvSpPr>
-          <p:cNvPr id="41" name="Text 39"/>
+            <a:endParaRPr lang="en-US" sz="1050" dirty="0"/>
+          </a:p>
+        </p:txBody>
+      </p:sp>
+      <p:sp>
+        <p:nvSpPr>
+          <p:cNvPr id="37" name="Text 35"/>
           <p:cNvSpPr txBox="1"/>
           <p:nvPr/>
         </p:nvSpPr>
         <p:spPr>
           <a:xfrm>
-            <a:off x="960120" y="3520440"/>
-            <a:ext cx="1508760" cy="384048"/>
+            <a:off x="914400" y="4069080"/>
+            <a:ext cx="1828800" cy="329184"/>
           </a:xfrm>
           <a:prstGeom prst="rect">
             <a:avLst/>
@@ -2209,7 +2053,7 @@
               <a:buNone/>
             </a:pPr>
             <a:r>
-              <a:rPr lang="en-US" sz="1300" b="1" dirty="0">
+              <a:rPr lang="en-US" sz="1250" b="1" dirty="0">
                 <a:solidFill>
                   <a:srgbClr val="123B3B"/>
                 </a:solidFill>
@@ -2219,20 +2063,20 @@
               </a:rPr>
               <a:t>고객 불편 / VOC</a:t>
             </a:r>
-            <a:endParaRPr lang="en-US" sz="1300" dirty="0"/>
-          </a:p>
-        </p:txBody>
-      </p:sp>
-      <p:sp>
-        <p:nvSpPr>
-          <p:cNvPr id="42" name="Text 40"/>
+            <a:endParaRPr lang="en-US" sz="1250" dirty="0"/>
+          </a:p>
+        </p:txBody>
+      </p:sp>
+      <p:sp>
+        <p:nvSpPr>
+          <p:cNvPr id="38" name="Text 36"/>
           <p:cNvSpPr txBox="1"/>
           <p:nvPr/>
         </p:nvSpPr>
         <p:spPr>
           <a:xfrm>
-            <a:off x="2240280" y="3520440"/>
-            <a:ext cx="1188720" cy="384048"/>
+            <a:off x="2697480" y="4069080"/>
+            <a:ext cx="1005840" cy="329184"/>
           </a:xfrm>
           <a:prstGeom prst="rect">
             <a:avLst/>
@@ -2248,7 +2092,7 @@
               <a:buNone/>
             </a:pPr>
             <a:r>
-              <a:rPr lang="en-US" sz="850" dirty="0">
+              <a:rPr lang="en-US" sz="750" dirty="0">
                 <a:solidFill>
                   <a:srgbClr val="6B6B6B"/>
                 </a:solidFill>
@@ -2258,59 +2102,20 @@
               </a:rPr>
               <a:t>CUSTOMER PAIN</a:t>
             </a:r>
-            <a:endParaRPr lang="en-US" sz="850" dirty="0"/>
-          </a:p>
-        </p:txBody>
-      </p:sp>
-      <p:sp>
-        <p:nvSpPr>
-          <p:cNvPr id="43" name="Card04Body"/>
-          <p:cNvSpPr txBox="1"/>
-          <p:nvPr/>
-        </p:nvSpPr>
-        <p:spPr>
-          <a:xfrm>
-            <a:off x="621792" y="3995928"/>
-            <a:ext cx="2779776" cy="2313432"/>
-          </a:xfrm>
-          <a:prstGeom prst="rect">
-            <a:avLst/>
-          </a:prstGeom>
-          <a:noFill/>
-          <a:ln/>
-        </p:spPr>
-        <p:txBody>
-          <a:bodyPr wrap="square" lIns="0" tIns="0" rIns="0" bIns="0" rtlCol="0" anchor="t"/>
-          <a:lstStyle/>
-          <a:p>
-            <a:pPr indent="0" marL="0">
-              <a:buNone/>
-            </a:pPr>
-            <a:r>
-              <a:rPr lang="en-US" sz="1050" dirty="0">
-                <a:solidFill>
-                  <a:srgbClr val="6B6B6B"/>
-                </a:solidFill>
-                <a:latin typeface="Malgun Gothic" pitchFamily="34" charset="0"/>
-                <a:ea typeface="Malgun Gothic" pitchFamily="34" charset="-122"/>
-                <a:cs typeface="Malgun Gothic" pitchFamily="34" charset="-120"/>
-              </a:rPr>
-              <a:t>고객은 누구이며 어떤 상황에서 무엇이 불편한가? 현재 알고 있는 고객의 말·행동·근거 또는 팀의 가설을 적습니다.</a:t>
-            </a:r>
-            <a:endParaRPr lang="en-US" sz="1050" dirty="0"/>
-          </a:p>
-        </p:txBody>
-      </p:sp>
-      <p:sp>
-        <p:nvSpPr>
-          <p:cNvPr id="44" name="Card05"/>
+            <a:endParaRPr lang="en-US" sz="750" dirty="0"/>
+          </a:p>
+        </p:txBody>
+      </p:sp>
+      <p:sp>
+        <p:nvSpPr>
+          <p:cNvPr id="39" name="Card05"/>
           <p:cNvSpPr/>
           <p:nvPr/>
         </p:nvSpPr>
         <p:spPr>
           <a:xfrm>
-            <a:off x="3749040" y="3520440"/>
-            <a:ext cx="3383280" cy="2880360"/>
+            <a:off x="3977640" y="4069080"/>
+            <a:ext cx="2542032" cy="2377440"/>
           </a:xfrm>
           <a:prstGeom prst="rect">
             <a:avLst/>
@@ -2328,14 +2133,14 @@
       </p:sp>
       <p:sp>
         <p:nvSpPr>
-          <p:cNvPr id="45" name="Card05Header"/>
+          <p:cNvPr id="40" name="Card05Header"/>
           <p:cNvSpPr/>
           <p:nvPr/>
         </p:nvSpPr>
         <p:spPr>
           <a:xfrm>
-            <a:off x="3749040" y="3520440"/>
-            <a:ext cx="3383280" cy="384048"/>
+            <a:off x="3977640" y="4069080"/>
+            <a:ext cx="2542032" cy="329184"/>
           </a:xfrm>
           <a:prstGeom prst="rect">
             <a:avLst/>
@@ -2353,14 +2158,14 @@
       </p:sp>
       <p:sp>
         <p:nvSpPr>
-          <p:cNvPr id="46" name="Text 44"/>
+          <p:cNvPr id="41" name="Text 39"/>
           <p:cNvSpPr txBox="1"/>
           <p:nvPr/>
         </p:nvSpPr>
         <p:spPr>
           <a:xfrm>
-            <a:off x="3886200" y="3520440"/>
-            <a:ext cx="365760" cy="384048"/>
+            <a:off x="4087368" y="4069080"/>
+            <a:ext cx="320040" cy="329184"/>
           </a:xfrm>
           <a:prstGeom prst="rect">
             <a:avLst/>
@@ -2376,7 +2181,7 @@
               <a:buNone/>
             </a:pPr>
             <a:r>
-              <a:rPr lang="en-US" sz="1100" dirty="0">
+              <a:rPr lang="en-US" sz="1050" dirty="0">
                 <a:solidFill>
                   <a:srgbClr val="1B8A7A"/>
                 </a:solidFill>
@@ -2386,20 +2191,20 @@
               </a:rPr>
               <a:t>05</a:t>
             </a:r>
-            <a:endParaRPr lang="en-US" sz="1100" dirty="0"/>
-          </a:p>
-        </p:txBody>
-      </p:sp>
-      <p:sp>
-        <p:nvSpPr>
-          <p:cNvPr id="47" name="Text 45"/>
+            <a:endParaRPr lang="en-US" sz="1050" dirty="0"/>
+          </a:p>
+        </p:txBody>
+      </p:sp>
+      <p:sp>
+        <p:nvSpPr>
+          <p:cNvPr id="42" name="Text 40"/>
           <p:cNvSpPr txBox="1"/>
           <p:nvPr/>
         </p:nvSpPr>
         <p:spPr>
           <a:xfrm>
-            <a:off x="4251960" y="3520440"/>
-            <a:ext cx="1783080" cy="384048"/>
+            <a:off x="4434840" y="4069080"/>
+            <a:ext cx="1033272" cy="329184"/>
           </a:xfrm>
           <a:prstGeom prst="rect">
             <a:avLst/>
@@ -2415,7 +2220,7 @@
               <a:buNone/>
             </a:pPr>
             <a:r>
-              <a:rPr lang="en-US" sz="1300" b="1" dirty="0">
+              <a:rPr lang="en-US" sz="1250" b="1" dirty="0">
                 <a:solidFill>
                   <a:srgbClr val="123B3B"/>
                 </a:solidFill>
@@ -2425,20 +2230,20 @@
               </a:rPr>
               <a:t>과제 일정</a:t>
             </a:r>
-            <a:endParaRPr lang="en-US" sz="1300" dirty="0"/>
-          </a:p>
-        </p:txBody>
-      </p:sp>
-      <p:sp>
-        <p:nvSpPr>
-          <p:cNvPr id="48" name="Text 46"/>
+            <a:endParaRPr lang="en-US" sz="1250" dirty="0"/>
+          </a:p>
+        </p:txBody>
+      </p:sp>
+      <p:sp>
+        <p:nvSpPr>
+          <p:cNvPr id="43" name="Text 41"/>
           <p:cNvSpPr txBox="1"/>
           <p:nvPr/>
         </p:nvSpPr>
         <p:spPr>
           <a:xfrm>
-            <a:off x="5806440" y="3520440"/>
-            <a:ext cx="1188720" cy="384048"/>
+            <a:off x="5422392" y="4069080"/>
+            <a:ext cx="1005840" cy="329184"/>
           </a:xfrm>
           <a:prstGeom prst="rect">
             <a:avLst/>
@@ -2454,7 +2259,7 @@
               <a:buNone/>
             </a:pPr>
             <a:r>
-              <a:rPr lang="en-US" sz="850" dirty="0">
+              <a:rPr lang="en-US" sz="750" dirty="0">
                 <a:solidFill>
                   <a:srgbClr val="6B6B6B"/>
                 </a:solidFill>
@@ -2464,20 +2269,20 @@
               </a:rPr>
               <a:t>MILESTONE</a:t>
             </a:r>
-            <a:endParaRPr lang="en-US" sz="850" dirty="0"/>
-          </a:p>
-        </p:txBody>
-      </p:sp>
-      <p:sp>
-        <p:nvSpPr>
-          <p:cNvPr id="49" name="Card06"/>
+            <a:endParaRPr lang="en-US" sz="750" dirty="0"/>
+          </a:p>
+        </p:txBody>
+      </p:sp>
+      <p:sp>
+        <p:nvSpPr>
+          <p:cNvPr id="44" name="Card06"/>
           <p:cNvSpPr/>
           <p:nvPr/>
         </p:nvSpPr>
         <p:spPr>
           <a:xfrm>
-            <a:off x="7315200" y="3520440"/>
-            <a:ext cx="4416552" cy="2880360"/>
+            <a:off x="6702552" y="4069080"/>
+            <a:ext cx="5029200" cy="2377440"/>
           </a:xfrm>
           <a:prstGeom prst="rect">
             <a:avLst/>
@@ -2495,14 +2300,14 @@
       </p:sp>
       <p:sp>
         <p:nvSpPr>
-          <p:cNvPr id="50" name="Card06Header"/>
+          <p:cNvPr id="45" name="Card06Header"/>
           <p:cNvSpPr/>
           <p:nvPr/>
         </p:nvSpPr>
         <p:spPr>
           <a:xfrm>
-            <a:off x="7315200" y="3520440"/>
-            <a:ext cx="4416552" cy="384048"/>
+            <a:off x="6702552" y="4069080"/>
+            <a:ext cx="5029200" cy="329184"/>
           </a:xfrm>
           <a:prstGeom prst="rect">
             <a:avLst/>
@@ -2520,14 +2325,14 @@
       </p:sp>
       <p:sp>
         <p:nvSpPr>
-          <p:cNvPr id="51" name="Text 49"/>
+          <p:cNvPr id="46" name="Text 44"/>
           <p:cNvSpPr txBox="1"/>
           <p:nvPr/>
         </p:nvSpPr>
         <p:spPr>
           <a:xfrm>
-            <a:off x="7452360" y="3520440"/>
-            <a:ext cx="365760" cy="384048"/>
+            <a:off x="6812280" y="4069080"/>
+            <a:ext cx="320040" cy="329184"/>
           </a:xfrm>
           <a:prstGeom prst="rect">
             <a:avLst/>
@@ -2543,7 +2348,7 @@
               <a:buNone/>
             </a:pPr>
             <a:r>
-              <a:rPr lang="en-US" sz="1100" dirty="0">
+              <a:rPr lang="en-US" sz="1050" dirty="0">
                 <a:solidFill>
                   <a:srgbClr val="1B8A7A"/>
                 </a:solidFill>
@@ -2553,20 +2358,20 @@
               </a:rPr>
               <a:t>06</a:t>
             </a:r>
-            <a:endParaRPr lang="en-US" sz="1100" dirty="0"/>
-          </a:p>
-        </p:txBody>
-      </p:sp>
-      <p:sp>
-        <p:nvSpPr>
-          <p:cNvPr id="52" name="Text 50"/>
+            <a:endParaRPr lang="en-US" sz="1050" dirty="0"/>
+          </a:p>
+        </p:txBody>
+      </p:sp>
+      <p:sp>
+        <p:nvSpPr>
+          <p:cNvPr id="47" name="Text 45"/>
           <p:cNvSpPr txBox="1"/>
           <p:nvPr/>
         </p:nvSpPr>
         <p:spPr>
           <a:xfrm>
-            <a:off x="7818120" y="3520440"/>
-            <a:ext cx="2816352" cy="384048"/>
+            <a:off x="7159752" y="4069080"/>
+            <a:ext cx="3520440" cy="329184"/>
           </a:xfrm>
           <a:prstGeom prst="rect">
             <a:avLst/>
@@ -2582,7 +2387,7 @@
               <a:buNone/>
             </a:pPr>
             <a:r>
-              <a:rPr lang="en-US" sz="1300" b="1" dirty="0">
+              <a:rPr lang="en-US" sz="1250" b="1" dirty="0">
                 <a:solidFill>
                   <a:srgbClr val="123B3B"/>
                 </a:solidFill>
@@ -2592,20 +2397,20 @@
               </a:rPr>
               <a:t>팀원 &amp; 역할</a:t>
             </a:r>
-            <a:endParaRPr lang="en-US" sz="1300" dirty="0"/>
-          </a:p>
-        </p:txBody>
-      </p:sp>
-      <p:sp>
-        <p:nvSpPr>
-          <p:cNvPr id="53" name="Text 51"/>
+            <a:endParaRPr lang="en-US" sz="1250" dirty="0"/>
+          </a:p>
+        </p:txBody>
+      </p:sp>
+      <p:sp>
+        <p:nvSpPr>
+          <p:cNvPr id="48" name="Text 46"/>
           <p:cNvSpPr txBox="1"/>
           <p:nvPr/>
         </p:nvSpPr>
         <p:spPr>
           <a:xfrm>
-            <a:off x="10405872" y="3520440"/>
-            <a:ext cx="1188720" cy="384048"/>
+            <a:off x="10634472" y="4069080"/>
+            <a:ext cx="1005840" cy="329184"/>
           </a:xfrm>
           <a:prstGeom prst="rect">
             <a:avLst/>
@@ -2621,7 +2426,7 @@
               <a:buNone/>
             </a:pPr>
             <a:r>
-              <a:rPr lang="en-US" sz="850" dirty="0">
+              <a:rPr lang="en-US" sz="750" dirty="0">
                 <a:solidFill>
                   <a:srgbClr val="6B6B6B"/>
                 </a:solidFill>
@@ -2631,20 +2436,20 @@
               </a:rPr>
               <a:t>TEAM &amp; ROLE</a:t>
             </a:r>
-            <a:endParaRPr lang="en-US" sz="850" dirty="0"/>
-          </a:p>
-        </p:txBody>
-      </p:sp>
-      <p:sp>
-        <p:nvSpPr>
-          <p:cNvPr id="54" name="Card05Body"/>
+            <a:endParaRPr lang="en-US" sz="750" dirty="0"/>
+          </a:p>
+        </p:txBody>
+      </p:sp>
+      <p:sp>
+        <p:nvSpPr>
+          <p:cNvPr id="49" name="Card01Body"/>
           <p:cNvSpPr txBox="1"/>
           <p:nvPr/>
         </p:nvSpPr>
         <p:spPr>
           <a:xfrm>
-            <a:off x="3913632" y="3995928"/>
-            <a:ext cx="3054096" cy="2313432"/>
+            <a:off x="594360" y="1773936"/>
+            <a:ext cx="5669280" cy="2103120"/>
           </a:xfrm>
           <a:prstGeom prst="rect">
             <a:avLst/>
@@ -2658,12 +2463,360 @@
           <a:p>
             <a:pPr indent="0" marL="0">
               <a:spcAft>
-                <a:spcPts val="400"/>
-              </a:spcAft>
-              <a:buNone/>
-            </a:pPr>
-            <a:r>
-              <a:rPr lang="en-US" sz="1100" b="1" dirty="0">
+                <a:spcPts val="200"/>
+              </a:spcAft>
+              <a:buNone/>
+            </a:pPr>
+            <a:r>
+              <a:rPr lang="en-US" sz="950" b="1" dirty="0">
+                <a:solidFill>
+                  <a:srgbClr val="1B8A7A"/>
+                </a:solidFill>
+                <a:latin typeface="Malgun Gothic" pitchFamily="34" charset="0"/>
+                <a:ea typeface="Malgun Gothic" pitchFamily="34" charset="-122"/>
+                <a:cs typeface="Malgun Gothic" pitchFamily="34" charset="-120"/>
+              </a:rPr>
+              <a:t>기업 관점</a:t>
+            </a:r>
+            <a:pPr indent="0" marL="0">
+              <a:spcAft>
+                <a:spcPts val="200"/>
+              </a:spcAft>
+              <a:buNone/>
+            </a:pPr>
+            <a:endParaRPr lang="en-US" sz="950" dirty="0"/>
+          </a:p>
+          <a:p>
+            <a:pPr indent="0" marL="0">
+              <a:spcAft>
+                <a:spcPts val="200"/>
+              </a:spcAft>
+              <a:buNone/>
+            </a:pPr>
+            <a:r>
+              <a:rPr lang="en-US" sz="950" dirty="0">
+                <a:solidFill>
+                  <a:srgbClr val="222222"/>
+                </a:solidFill>
+                <a:latin typeface="Malgun Gothic" pitchFamily="34" charset="0"/>
+                <a:ea typeface="Malgun Gothic" pitchFamily="34" charset="-122"/>
+                <a:cs typeface="Malgun Gothic" pitchFamily="34" charset="-120"/>
+              </a:rPr>
+              <a:t>1. 채널 확대를 통한 주요 아이템 매출 증대 목표</a:t>
+            </a:r>
+            <a:endParaRPr lang="en-US" sz="950" dirty="0"/>
+          </a:p>
+          <a:p>
+            <a:pPr indent="0" marL="0">
+              <a:spcAft>
+                <a:spcPts val="200"/>
+              </a:spcAft>
+              <a:buNone/>
+            </a:pPr>
+            <a:r>
+              <a:rPr lang="en-US" sz="950" dirty="0">
+                <a:solidFill>
+                  <a:srgbClr val="222222"/>
+                </a:solidFill>
+                <a:latin typeface="Malgun Gothic" pitchFamily="34" charset="0"/>
+                <a:ea typeface="Malgun Gothic" pitchFamily="34" charset="-122"/>
+                <a:cs typeface="Malgun Gothic" pitchFamily="34" charset="-120"/>
+              </a:rPr>
+              <a:t>2. 타깃 고객 대상 브랜드 핵심 메세지 전달(공감 &amp; 신뢰 구축)</a:t>
+            </a:r>
+            <a:endParaRPr lang="en-US" sz="950" dirty="0"/>
+          </a:p>
+          <a:p>
+            <a:pPr indent="0" marL="0">
+              <a:spcAft>
+                <a:spcPts val="200"/>
+              </a:spcAft>
+              <a:buNone/>
+            </a:pPr>
+            <a:r>
+              <a:rPr lang="en-US" sz="950" dirty="0">
+                <a:solidFill>
+                  <a:srgbClr val="222222"/>
+                </a:solidFill>
+                <a:latin typeface="Malgun Gothic" pitchFamily="34" charset="0"/>
+                <a:ea typeface="Malgun Gothic" pitchFamily="34" charset="-122"/>
+                <a:cs typeface="Malgun Gothic" pitchFamily="34" charset="-120"/>
+              </a:rPr>
+              <a:t>3. 핵심 메세지가 담긴 컨텐츠 및 SNS 시안을 통한 커뮤니케이션 확대</a:t>
+            </a:r>
+            <a:endParaRPr lang="en-US" sz="950" dirty="0"/>
+          </a:p>
+          <a:p>
+            <a:pPr indent="0" marL="0">
+              <a:spcAft>
+                <a:spcPts val="200"/>
+              </a:spcAft>
+              <a:buNone/>
+            </a:pPr>
+            <a:r>
+              <a:rPr lang="en-US" sz="950" b="1" dirty="0">
+                <a:solidFill>
+                  <a:srgbClr val="1B8A7A"/>
+                </a:solidFill>
+                <a:latin typeface="Malgun Gothic" pitchFamily="34" charset="0"/>
+                <a:ea typeface="Malgun Gothic" pitchFamily="34" charset="-122"/>
+                <a:cs typeface="Malgun Gothic" pitchFamily="34" charset="-120"/>
+              </a:rPr>
+              <a:t>고객 관점</a:t>
+            </a:r>
+            <a:pPr indent="0" marL="0">
+              <a:spcAft>
+                <a:spcPts val="200"/>
+              </a:spcAft>
+              <a:buNone/>
+            </a:pPr>
+            <a:endParaRPr lang="en-US" sz="950" dirty="0"/>
+          </a:p>
+          <a:p>
+            <a:pPr indent="0" marL="0">
+              <a:spcAft>
+                <a:spcPts val="200"/>
+              </a:spcAft>
+              <a:buNone/>
+            </a:pPr>
+            <a:r>
+              <a:rPr lang="en-US" sz="950" dirty="0">
+                <a:solidFill>
+                  <a:srgbClr val="222222"/>
+                </a:solidFill>
+                <a:latin typeface="Malgun Gothic" pitchFamily="34" charset="0"/>
+                <a:ea typeface="Malgun Gothic" pitchFamily="34" charset="-122"/>
+                <a:cs typeface="Malgun Gothic" pitchFamily="34" charset="-120"/>
+              </a:rPr>
+              <a:t>신생 브랜드라 인지도와 신뢰를 쌓아야 하며, 다음 성장 단계도 필요하다고 판단. 국내 암환자들이 안심하고 사용할 수 있는 국내 브랜드가 필요</a:t>
+            </a:r>
+            <a:endParaRPr lang="en-US" sz="950" dirty="0"/>
+          </a:p>
+          <a:p>
+            <a:pPr indent="0" marL="0">
+              <a:spcAft>
+                <a:spcPts val="200"/>
+              </a:spcAft>
+              <a:buNone/>
+            </a:pPr>
+            <a:r>
+              <a:rPr lang="en-US" sz="950" b="1" dirty="0">
+                <a:solidFill>
+                  <a:srgbClr val="1B8A7A"/>
+                </a:solidFill>
+                <a:latin typeface="Malgun Gothic" pitchFamily="34" charset="0"/>
+                <a:ea typeface="Malgun Gothic" pitchFamily="34" charset="-122"/>
+                <a:cs typeface="Malgun Gothic" pitchFamily="34" charset="-120"/>
+              </a:rPr>
+              <a:t>시장 관점</a:t>
+            </a:r>
+            <a:pPr indent="0" marL="0">
+              <a:spcAft>
+                <a:spcPts val="200"/>
+              </a:spcAft>
+              <a:buNone/>
+            </a:pPr>
+            <a:endParaRPr lang="en-US" sz="950" dirty="0"/>
+          </a:p>
+          <a:p>
+            <a:pPr indent="0" marL="0">
+              <a:spcAft>
+                <a:spcPts val="200"/>
+              </a:spcAft>
+              <a:buNone/>
+            </a:pPr>
+            <a:r>
+              <a:rPr lang="en-US" sz="950" dirty="0">
+                <a:solidFill>
+                  <a:srgbClr val="222222"/>
+                </a:solidFill>
+                <a:latin typeface="Malgun Gothic" pitchFamily="34" charset="0"/>
+                <a:ea typeface="Malgun Gothic" pitchFamily="34" charset="-122"/>
+                <a:cs typeface="Malgun Gothic" pitchFamily="34" charset="-120"/>
+              </a:rPr>
+              <a:t>국내 암 유병자는 2023년 기준 273만 명으로 국민 19명 중 1명이며, 5년 생존율이 73.7%에 이르러 암을 겪은 후에도 오래 일상을 살아가는 사람이 늘고 있습니다. 그러나 이들은 치료 과정에서 피부 변화와 성분에 대한 불안을 겪으면서도, 어떤 제품을 믿고 써도 되는지 판단할 근거를 얻기 어렵습니다. 라파앤코는 암 환자 맞춤형 피부 솔루션이라는 전문성을 갖고 있으나, 이를 고객이 안심할 수 있는 신뢰로 전달하는 구조가 필요합니다.</a:t>
+            </a:r>
+            <a:endParaRPr lang="en-US" sz="950" dirty="0"/>
+          </a:p>
+        </p:txBody>
+      </p:sp>
+      <p:sp>
+        <p:nvSpPr>
+          <p:cNvPr id="50" name="Card02Body"/>
+          <p:cNvSpPr txBox="1"/>
+          <p:nvPr/>
+        </p:nvSpPr>
+        <p:spPr>
+          <a:xfrm>
+            <a:off x="6720840" y="1773936"/>
+            <a:ext cx="2468880" cy="2103120"/>
+          </a:xfrm>
+          <a:prstGeom prst="rect">
+            <a:avLst/>
+          </a:prstGeom>
+          <a:noFill/>
+          <a:ln/>
+        </p:spPr>
+        <p:txBody>
+          <a:bodyPr wrap="square" lIns="0" tIns="0" rIns="0" bIns="0" rtlCol="0" anchor="t"/>
+          <a:lstStyle/>
+          <a:p>
+            <a:pPr marL="342900" indent="-342900">
+              <a:spcAft>
+                <a:spcPts val="200"/>
+              </a:spcAft>
+              <a:buSzPct val="100000"/>
+              <a:buChar char="•"/>
+            </a:pPr>
+            <a:r>
+              <a:rPr lang="en-US" sz="1000" dirty="0">
+                <a:solidFill>
+                  <a:srgbClr val="222222"/>
+                </a:solidFill>
+                <a:latin typeface="Malgun Gothic" pitchFamily="34" charset="0"/>
+                <a:ea typeface="Malgun Gothic" pitchFamily="34" charset="-122"/>
+                <a:cs typeface="Malgun Gothic" pitchFamily="34" charset="-120"/>
+              </a:rPr>
+              <a:t>B2C/B2B 타깃 세분화·페르소나</a:t>
+            </a:r>
+            <a:endParaRPr lang="en-US" sz="1000" dirty="0"/>
+          </a:p>
+          <a:p>
+            <a:pPr marL="342900" indent="-342900">
+              <a:spcAft>
+                <a:spcPts val="200"/>
+              </a:spcAft>
+              <a:buSzPct val="100000"/>
+              <a:buChar char="•"/>
+            </a:pPr>
+            <a:r>
+              <a:rPr lang="en-US" sz="1000" dirty="0">
+                <a:solidFill>
+                  <a:srgbClr val="222222"/>
+                </a:solidFill>
+                <a:latin typeface="Malgun Gothic" pitchFamily="34" charset="0"/>
+                <a:ea typeface="Malgun Gothic" pitchFamily="34" charset="-122"/>
+                <a:cs typeface="Malgun Gothic" pitchFamily="34" charset="-120"/>
+              </a:rPr>
+              <a:t>타깃별 USP·핵심 메시지</a:t>
+            </a:r>
+            <a:endParaRPr lang="en-US" sz="1000" dirty="0"/>
+          </a:p>
+          <a:p>
+            <a:pPr marL="342900" indent="-342900">
+              <a:spcAft>
+                <a:spcPts val="200"/>
+              </a:spcAft>
+              <a:buSzPct val="100000"/>
+              <a:buChar char="•"/>
+            </a:pPr>
+            <a:r>
+              <a:rPr lang="en-US" sz="1000" dirty="0">
+                <a:solidFill>
+                  <a:srgbClr val="222222"/>
+                </a:solidFill>
+                <a:latin typeface="Malgun Gothic" pitchFamily="34" charset="0"/>
+                <a:ea typeface="Malgun Gothic" pitchFamily="34" charset="-122"/>
+                <a:cs typeface="Malgun Gothic" pitchFamily="34" charset="-120"/>
+              </a:rPr>
+              <a:t>B2C 4주 콘텐츠 플랜과 SNS 시안 3개</a:t>
+            </a:r>
+            <a:endParaRPr lang="en-US" sz="1000" dirty="0"/>
+          </a:p>
+          <a:p>
+            <a:pPr marL="342900" indent="-342900">
+              <a:spcAft>
+                <a:spcPts val="200"/>
+              </a:spcAft>
+              <a:buSzPct val="100000"/>
+              <a:buChar char="•"/>
+            </a:pPr>
+            <a:r>
+              <a:rPr lang="en-US" sz="1000" dirty="0">
+                <a:solidFill>
+                  <a:srgbClr val="222222"/>
+                </a:solidFill>
+                <a:latin typeface="Malgun Gothic" pitchFamily="34" charset="0"/>
+                <a:ea typeface="Malgun Gothic" pitchFamily="34" charset="-122"/>
+                <a:cs typeface="Malgun Gothic" pitchFamily="34" charset="-120"/>
+              </a:rPr>
+              <a:t>Landing/FAQ(구매전환) 구조 1안</a:t>
+            </a:r>
+            <a:endParaRPr lang="en-US" sz="1000" dirty="0"/>
+          </a:p>
+          <a:p>
+            <a:pPr marL="342900" indent="-342900">
+              <a:spcAft>
+                <a:spcPts val="200"/>
+              </a:spcAft>
+              <a:buSzPct val="100000"/>
+              <a:buChar char="•"/>
+            </a:pPr>
+            <a:r>
+              <a:rPr lang="en-US" sz="1000" dirty="0">
+                <a:solidFill>
+                  <a:srgbClr val="222222"/>
+                </a:solidFill>
+                <a:latin typeface="Malgun Gothic" pitchFamily="34" charset="0"/>
+                <a:ea typeface="Malgun Gothic" pitchFamily="34" charset="-122"/>
+                <a:cs typeface="Malgun Gothic" pitchFamily="34" charset="-120"/>
+              </a:rPr>
+              <a:t>B2B Partner Map·제휴 제안서 Skeleton·Contact Action Plan</a:t>
+            </a:r>
+            <a:endParaRPr lang="en-US" sz="1000" dirty="0"/>
+          </a:p>
+          <a:p>
+            <a:pPr marL="342900" indent="-342900">
+              <a:spcAft>
+                <a:spcPts val="200"/>
+              </a:spcAft>
+              <a:buSzPct val="100000"/>
+              <a:buChar char="•"/>
+            </a:pPr>
+            <a:r>
+              <a:rPr lang="en-US" sz="1000" dirty="0">
+                <a:solidFill>
+                  <a:srgbClr val="222222"/>
+                </a:solidFill>
+                <a:latin typeface="Malgun Gothic" pitchFamily="34" charset="0"/>
+                <a:ea typeface="Malgun Gothic" pitchFamily="34" charset="-122"/>
+                <a:cs typeface="Malgun Gothic" pitchFamily="34" charset="-120"/>
+              </a:rPr>
+              <a:t>KPI 가설</a:t>
+            </a:r>
+            <a:endParaRPr lang="en-US" sz="1000" dirty="0"/>
+          </a:p>
+        </p:txBody>
+      </p:sp>
+      <p:sp>
+        <p:nvSpPr>
+          <p:cNvPr id="51" name="Card03Body"/>
+          <p:cNvSpPr txBox="1"/>
+          <p:nvPr/>
+        </p:nvSpPr>
+        <p:spPr>
+          <a:xfrm>
+            <a:off x="9646920" y="1773936"/>
+            <a:ext cx="1947672" cy="2103120"/>
+          </a:xfrm>
+          <a:prstGeom prst="rect">
+            <a:avLst/>
+          </a:prstGeom>
+          <a:noFill/>
+          <a:ln/>
+        </p:spPr>
+        <p:txBody>
+          <a:bodyPr wrap="square" lIns="0" tIns="0" rIns="0" bIns="0" rtlCol="0" anchor="t"/>
+          <a:lstStyle/>
+          <a:p>
+            <a:pPr indent="0" marL="0">
+              <a:spcAft>
+                <a:spcPts val="200"/>
+              </a:spcAft>
+              <a:buNone/>
+            </a:pPr>
+            <a:r>
+              <a:rPr lang="en-US" sz="1000" b="1" dirty="0">
                 <a:solidFill>
                   <a:srgbClr val="123B3B"/>
                 </a:solidFill>
@@ -2671,16 +2824,240 @@
                 <a:ea typeface="Malgun Gothic" pitchFamily="34" charset="-122"/>
                 <a:cs typeface="Malgun Gothic" pitchFamily="34" charset="-120"/>
               </a:rPr>
+              <a:t>라파앤코의 브랜드 인지도 확대를 통한 키아이템 매출 성장</a:t>
+            </a:r>
+            <a:endParaRPr lang="en-US" sz="1000" dirty="0"/>
+          </a:p>
+          <a:p>
+            <a:pPr indent="0" marL="0">
+              <a:spcAft>
+                <a:spcPts val="200"/>
+              </a:spcAft>
+              <a:buNone/>
+            </a:pPr>
+            <a:r>
+              <a:rPr lang="en-US" sz="1000" b="1" dirty="0">
+                <a:solidFill>
+                  <a:srgbClr val="1B8A7A"/>
+                </a:solidFill>
+                <a:latin typeface="Malgun Gothic" pitchFamily="34" charset="0"/>
+                <a:ea typeface="Malgun Gothic" pitchFamily="34" charset="-122"/>
+                <a:cs typeface="Malgun Gothic" pitchFamily="34" charset="-120"/>
+              </a:rPr>
+              <a:t>대상</a:t>
+            </a:r>
+            <a:pPr indent="0" marL="0">
+              <a:spcAft>
+                <a:spcPts val="200"/>
+              </a:spcAft>
+              <a:buNone/>
+            </a:pPr>
+            <a:endParaRPr lang="en-US" sz="1000" dirty="0"/>
+          </a:p>
+          <a:p>
+            <a:pPr indent="0" marL="0">
+              <a:spcAft>
+                <a:spcPts val="200"/>
+              </a:spcAft>
+              <a:buNone/>
+            </a:pPr>
+            <a:r>
+              <a:rPr lang="en-US" sz="1000" dirty="0">
+                <a:solidFill>
+                  <a:srgbClr val="222222"/>
+                </a:solidFill>
+                <a:latin typeface="Malgun Gothic" pitchFamily="34" charset="0"/>
+                <a:ea typeface="Malgun Gothic" pitchFamily="34" charset="-122"/>
+                <a:cs typeface="Malgun Gothic" pitchFamily="34" charset="-120"/>
+              </a:rPr>
+              <a:t>암환자 및 가족 + 의료직군대상</a:t>
+            </a:r>
+            <a:endParaRPr lang="en-US" sz="1000" dirty="0"/>
+          </a:p>
+        </p:txBody>
+      </p:sp>
+      <p:sp>
+        <p:nvSpPr>
+          <p:cNvPr id="52" name="Card04Body"/>
+          <p:cNvSpPr txBox="1"/>
+          <p:nvPr/>
+        </p:nvSpPr>
+        <p:spPr>
+          <a:xfrm>
+            <a:off x="594360" y="4471416"/>
+            <a:ext cx="3063240" cy="1920240"/>
+          </a:xfrm>
+          <a:prstGeom prst="rect">
+            <a:avLst/>
+          </a:prstGeom>
+          <a:noFill/>
+          <a:ln/>
+        </p:spPr>
+        <p:txBody>
+          <a:bodyPr wrap="square" lIns="0" tIns="0" rIns="0" bIns="0" rtlCol="0" anchor="t"/>
+          <a:lstStyle/>
+          <a:p>
+            <a:pPr indent="0" marL="0">
+              <a:spcAft>
+                <a:spcPts val="200"/>
+              </a:spcAft>
+              <a:buNone/>
+            </a:pPr>
+            <a:r>
+              <a:rPr lang="en-US" sz="950" b="1" dirty="0">
+                <a:solidFill>
+                  <a:srgbClr val="1B8A7A"/>
+                </a:solidFill>
+                <a:latin typeface="Malgun Gothic" pitchFamily="34" charset="0"/>
+                <a:ea typeface="Malgun Gothic" pitchFamily="34" charset="-122"/>
+                <a:cs typeface="Malgun Gothic" pitchFamily="34" charset="-120"/>
+              </a:rPr>
+              <a:t>B2C</a:t>
+            </a:r>
+            <a:pPr indent="0" marL="0">
+              <a:spcAft>
+                <a:spcPts val="200"/>
+              </a:spcAft>
+              <a:buNone/>
+            </a:pPr>
+            <a:r>
+              <a:rPr lang="en-US" sz="950" b="1" dirty="0">
+                <a:solidFill>
+                  <a:srgbClr val="123B3B"/>
+                </a:solidFill>
+                <a:latin typeface="Malgun Gothic" pitchFamily="34" charset="0"/>
+                <a:ea typeface="Malgun Gothic" pitchFamily="34" charset="-122"/>
+                <a:cs typeface="Malgun Gothic" pitchFamily="34" charset="-120"/>
+              </a:rPr>
+              <a:t> 환자 본인·가족/친구·문제성 피부 고객</a:t>
+            </a:r>
+            <a:endParaRPr lang="en-US" sz="950" dirty="0"/>
+          </a:p>
+          <a:p>
+            <a:pPr indent="0" marL="0">
+              <a:spcAft>
+                <a:spcPts val="200"/>
+              </a:spcAft>
+              <a:buNone/>
+            </a:pPr>
+            <a:r>
+              <a:rPr lang="en-US" sz="950" dirty="0">
+                <a:solidFill>
+                  <a:srgbClr val="222222"/>
+                </a:solidFill>
+                <a:latin typeface="Malgun Gothic" pitchFamily="34" charset="0"/>
+                <a:ea typeface="Malgun Gothic" pitchFamily="34" charset="-122"/>
+                <a:cs typeface="Malgun Gothic" pitchFamily="34" charset="-120"/>
+              </a:rPr>
+              <a:t>투병 중 달라진 피부에 무엇을 써도 불안하고 과장 광고와 의학적 오해를 부르는 표현에 거부감을 느껴, 구매 전 비교/검증 과정에서 믿을만한 근거가 필요</a:t>
+            </a:r>
+            <a:endParaRPr lang="en-US" sz="950" dirty="0"/>
+          </a:p>
+          <a:p>
+            <a:pPr indent="0" marL="0">
+              <a:spcAft>
+                <a:spcPts val="200"/>
+              </a:spcAft>
+              <a:buNone/>
+            </a:pPr>
+            <a:r>
+              <a:rPr lang="en-US" sz="950" b="1" dirty="0">
+                <a:solidFill>
+                  <a:srgbClr val="1B8A7A"/>
+                </a:solidFill>
+                <a:latin typeface="Malgun Gothic" pitchFamily="34" charset="0"/>
+                <a:ea typeface="Malgun Gothic" pitchFamily="34" charset="-122"/>
+                <a:cs typeface="Malgun Gothic" pitchFamily="34" charset="-120"/>
+              </a:rPr>
+              <a:t>B2B</a:t>
+            </a:r>
+            <a:pPr indent="0" marL="0">
+              <a:spcAft>
+                <a:spcPts val="200"/>
+              </a:spcAft>
+              <a:buNone/>
+            </a:pPr>
+            <a:r>
+              <a:rPr lang="en-US" sz="950" b="1" dirty="0">
+                <a:solidFill>
+                  <a:srgbClr val="123B3B"/>
+                </a:solidFill>
+                <a:latin typeface="Malgun Gothic" pitchFamily="34" charset="0"/>
+                <a:ea typeface="Malgun Gothic" pitchFamily="34" charset="-122"/>
+                <a:cs typeface="Malgun Gothic" pitchFamily="34" charset="-120"/>
+              </a:rPr>
+              <a:t> 암 커뮤니티·복지기관·암센터</a:t>
+            </a:r>
+            <a:endParaRPr lang="en-US" sz="950" dirty="0"/>
+          </a:p>
+          <a:p>
+            <a:pPr indent="0" marL="0">
+              <a:spcAft>
+                <a:spcPts val="200"/>
+              </a:spcAft>
+              <a:buNone/>
+            </a:pPr>
+            <a:r>
+              <a:rPr lang="en-US" sz="950" dirty="0">
+                <a:solidFill>
+                  <a:srgbClr val="222222"/>
+                </a:solidFill>
+                <a:latin typeface="Malgun Gothic" pitchFamily="34" charset="0"/>
+                <a:ea typeface="Malgun Gothic" pitchFamily="34" charset="-122"/>
+                <a:cs typeface="Malgun Gothic" pitchFamily="34" charset="-120"/>
+              </a:rPr>
+              <a:t>브랜드 소개만으로는 협력 이유를 알기 어렵고, 교육·샘플·복지 연계처럼 실행 가능한 제휴 모델과 후속 접촉 방식이 필요</a:t>
+            </a:r>
+            <a:endParaRPr lang="en-US" sz="950" dirty="0"/>
+          </a:p>
+        </p:txBody>
+      </p:sp>
+      <p:sp>
+        <p:nvSpPr>
+          <p:cNvPr id="53" name="Card05Body"/>
+          <p:cNvSpPr txBox="1"/>
+          <p:nvPr/>
+        </p:nvSpPr>
+        <p:spPr>
+          <a:xfrm>
+            <a:off x="4114800" y="4471416"/>
+            <a:ext cx="2267712" cy="1920240"/>
+          </a:xfrm>
+          <a:prstGeom prst="rect">
+            <a:avLst/>
+          </a:prstGeom>
+          <a:noFill/>
+          <a:ln/>
+        </p:spPr>
+        <p:txBody>
+          <a:bodyPr wrap="square" lIns="0" tIns="0" rIns="0" bIns="0" rtlCol="0" anchor="t"/>
+          <a:lstStyle/>
+          <a:p>
+            <a:pPr indent="0" marL="0">
+              <a:spcAft>
+                <a:spcPts val="200"/>
+              </a:spcAft>
+              <a:buNone/>
+            </a:pPr>
+            <a:r>
+              <a:rPr lang="en-US" sz="950" b="1" dirty="0">
+                <a:solidFill>
+                  <a:srgbClr val="123B3B"/>
+                </a:solidFill>
+                <a:latin typeface="Malgun Gothic" pitchFamily="34" charset="0"/>
+                <a:ea typeface="Malgun Gothic" pitchFamily="34" charset="-122"/>
+                <a:cs typeface="Malgun Gothic" pitchFamily="34" charset="-120"/>
+              </a:rPr>
               <a:t>1. 문제정의·Team Charter</a:t>
             </a:r>
             <a:pPr indent="0" marL="0">
               <a:spcAft>
-                <a:spcPts val="400"/>
-              </a:spcAft>
-              <a:buNone/>
-            </a:pPr>
-            <a:r>
-              <a:rPr lang="en-US" sz="1100" b="1" dirty="0">
+                <a:spcPts val="200"/>
+              </a:spcAft>
+              <a:buNone/>
+            </a:pPr>
+            <a:r>
+              <a:rPr lang="en-US" sz="950" b="1" dirty="0">
                 <a:solidFill>
                   <a:srgbClr val="1B8A7A"/>
                 </a:solidFill>
@@ -2690,17 +3067,17 @@
               </a:rPr>
               <a:t>  (1주)</a:t>
             </a:r>
-            <a:endParaRPr lang="en-US" sz="1100" dirty="0"/>
-          </a:p>
-          <a:p>
-            <a:pPr indent="0" marL="0">
-              <a:spcAft>
-                <a:spcPts val="400"/>
-              </a:spcAft>
-              <a:buNone/>
-            </a:pPr>
-            <a:r>
-              <a:rPr lang="en-US" sz="1100" b="1" dirty="0">
+            <a:endParaRPr lang="en-US" sz="950" dirty="0"/>
+          </a:p>
+          <a:p>
+            <a:pPr indent="0" marL="0">
+              <a:spcAft>
+                <a:spcPts val="200"/>
+              </a:spcAft>
+              <a:buNone/>
+            </a:pPr>
+            <a:r>
+              <a:rPr lang="en-US" sz="950" b="1" dirty="0">
                 <a:solidFill>
                   <a:srgbClr val="123B3B"/>
                 </a:solidFill>
@@ -2712,12 +3089,12 @@
             </a:r>
             <a:pPr indent="0" marL="0">
               <a:spcAft>
-                <a:spcPts val="400"/>
-              </a:spcAft>
-              <a:buNone/>
-            </a:pPr>
-            <a:r>
-              <a:rPr lang="en-US" sz="1100" b="1" dirty="0">
+                <a:spcPts val="200"/>
+              </a:spcAft>
+              <a:buNone/>
+            </a:pPr>
+            <a:r>
+              <a:rPr lang="en-US" sz="950" b="1" dirty="0">
                 <a:solidFill>
                   <a:srgbClr val="1B8A7A"/>
                 </a:solidFill>
@@ -2729,21 +3106,21 @@
             </a:r>
             <a:pPr indent="0" marL="0">
               <a:spcAft>
-                <a:spcPts val="400"/>
-              </a:spcAft>
-              <a:buNone/>
-            </a:pPr>
-            <a:endParaRPr lang="en-US" sz="1100" dirty="0"/>
-          </a:p>
-          <a:p>
-            <a:pPr indent="0" marL="0">
-              <a:spcAft>
-                <a:spcPts val="400"/>
-              </a:spcAft>
-              <a:buNone/>
-            </a:pPr>
-            <a:r>
-              <a:rPr lang="en-US" sz="1100" dirty="0">
+                <a:spcPts val="200"/>
+              </a:spcAft>
+              <a:buNone/>
+            </a:pPr>
+            <a:endParaRPr lang="en-US" sz="950" dirty="0"/>
+          </a:p>
+          <a:p>
+            <a:pPr indent="0" marL="0">
+              <a:spcAft>
+                <a:spcPts val="200"/>
+              </a:spcAft>
+              <a:buNone/>
+            </a:pPr>
+            <a:r>
+              <a:rPr lang="en-US" sz="950" dirty="0">
                 <a:solidFill>
                   <a:srgbClr val="222222"/>
                 </a:solidFill>
@@ -2753,17 +3130,17 @@
               </a:rPr>
               <a:t>브랜드, 경쟁사, VOC, 파트너 후보</a:t>
             </a:r>
-            <a:endParaRPr lang="en-US" sz="1100" dirty="0"/>
-          </a:p>
-          <a:p>
-            <a:pPr indent="0" marL="0">
-              <a:spcAft>
-                <a:spcPts val="400"/>
-              </a:spcAft>
-              <a:buNone/>
-            </a:pPr>
-            <a:r>
-              <a:rPr lang="en-US" sz="1100" b="1" dirty="0">
+            <a:endParaRPr lang="en-US" sz="950" dirty="0"/>
+          </a:p>
+          <a:p>
+            <a:pPr indent="0" marL="0">
+              <a:spcAft>
+                <a:spcPts val="200"/>
+              </a:spcAft>
+              <a:buNone/>
+            </a:pPr>
+            <a:r>
+              <a:rPr lang="en-US" sz="950" b="1" dirty="0">
                 <a:solidFill>
                   <a:srgbClr val="123B3B"/>
                 </a:solidFill>
@@ -2775,12 +3152,12 @@
             </a:r>
             <a:pPr indent="0" marL="0">
               <a:spcAft>
-                <a:spcPts val="400"/>
-              </a:spcAft>
-              <a:buNone/>
-            </a:pPr>
-            <a:r>
-              <a:rPr lang="en-US" sz="1100" b="1" dirty="0">
+                <a:spcPts val="200"/>
+              </a:spcAft>
+              <a:buNone/>
+            </a:pPr>
+            <a:r>
+              <a:rPr lang="en-US" sz="950" b="1" dirty="0">
                 <a:solidFill>
                   <a:srgbClr val="1B8A7A"/>
                 </a:solidFill>
@@ -2792,21 +3169,21 @@
             </a:r>
             <a:pPr indent="0" marL="0">
               <a:spcAft>
-                <a:spcPts val="400"/>
-              </a:spcAft>
-              <a:buNone/>
-            </a:pPr>
-            <a:endParaRPr lang="en-US" sz="1100" dirty="0"/>
-          </a:p>
-          <a:p>
-            <a:pPr indent="0" marL="0">
-              <a:spcAft>
-                <a:spcPts val="400"/>
-              </a:spcAft>
-              <a:buNone/>
-            </a:pPr>
-            <a:r>
-              <a:rPr lang="en-US" sz="1100" dirty="0">
+                <a:spcPts val="200"/>
+              </a:spcAft>
+              <a:buNone/>
+            </a:pPr>
+            <a:endParaRPr lang="en-US" sz="950" dirty="0"/>
+          </a:p>
+          <a:p>
+            <a:pPr indent="0" marL="0">
+              <a:spcAft>
+                <a:spcPts val="200"/>
+              </a:spcAft>
+              <a:buNone/>
+            </a:pPr>
+            <a:r>
+              <a:rPr lang="en-US" sz="950" dirty="0">
                 <a:solidFill>
                   <a:srgbClr val="222222"/>
                 </a:solidFill>
@@ -2816,17 +3193,17 @@
               </a:rPr>
               <a:t>세분화·페르소나, USP·메시지</a:t>
             </a:r>
-            <a:endParaRPr lang="en-US" sz="1100" dirty="0"/>
-          </a:p>
-          <a:p>
-            <a:pPr indent="0" marL="0">
-              <a:spcAft>
-                <a:spcPts val="400"/>
-              </a:spcAft>
-              <a:buNone/>
-            </a:pPr>
-            <a:r>
-              <a:rPr lang="en-US" sz="1100" b="1" dirty="0">
+            <a:endParaRPr lang="en-US" sz="950" dirty="0"/>
+          </a:p>
+          <a:p>
+            <a:pPr indent="0" marL="0">
+              <a:spcAft>
+                <a:spcPts val="200"/>
+              </a:spcAft>
+              <a:buNone/>
+            </a:pPr>
+            <a:r>
+              <a:rPr lang="en-US" sz="950" b="1" dirty="0">
                 <a:solidFill>
                   <a:srgbClr val="123B3B"/>
                 </a:solidFill>
@@ -2838,12 +3215,12 @@
             </a:r>
             <a:pPr indent="0" marL="0">
               <a:spcAft>
-                <a:spcPts val="400"/>
-              </a:spcAft>
-              <a:buNone/>
-            </a:pPr>
-            <a:r>
-              <a:rPr lang="en-US" sz="1100" b="1" dirty="0">
+                <a:spcPts val="200"/>
+              </a:spcAft>
+              <a:buNone/>
+            </a:pPr>
+            <a:r>
+              <a:rPr lang="en-US" sz="950" b="1" dirty="0">
                 <a:solidFill>
                   <a:srgbClr val="1B8A7A"/>
                 </a:solidFill>
@@ -2855,21 +3232,21 @@
             </a:r>
             <a:pPr indent="0" marL="0">
               <a:spcAft>
-                <a:spcPts val="400"/>
-              </a:spcAft>
-              <a:buNone/>
-            </a:pPr>
-            <a:endParaRPr lang="en-US" sz="1100" dirty="0"/>
-          </a:p>
-          <a:p>
-            <a:pPr indent="0" marL="0">
-              <a:spcAft>
-                <a:spcPts val="400"/>
-              </a:spcAft>
-              <a:buNone/>
-            </a:pPr>
-            <a:r>
-              <a:rPr lang="en-US" sz="1100" dirty="0">
+                <a:spcPts val="200"/>
+              </a:spcAft>
+              <a:buNone/>
+            </a:pPr>
+            <a:endParaRPr lang="en-US" sz="950" dirty="0"/>
+          </a:p>
+          <a:p>
+            <a:pPr indent="0" marL="0">
+              <a:spcAft>
+                <a:spcPts val="200"/>
+              </a:spcAft>
+              <a:buNone/>
+            </a:pPr>
+            <a:r>
+              <a:rPr lang="en-US" sz="950" dirty="0">
                 <a:solidFill>
                   <a:srgbClr val="222222"/>
                 </a:solidFill>
@@ -2879,17 +3256,17 @@
               </a:rPr>
               <a:t>4주 콘텐츠 플랜, SNS 시안 3개, 랜딩/FAQ 구조, B2B 제휴 뼈대</a:t>
             </a:r>
-            <a:endParaRPr lang="en-US" sz="1100" dirty="0"/>
-          </a:p>
-          <a:p>
-            <a:pPr indent="0" marL="0">
-              <a:spcAft>
-                <a:spcPts val="400"/>
-              </a:spcAft>
-              <a:buNone/>
-            </a:pPr>
-            <a:r>
-              <a:rPr lang="en-US" sz="1100" b="1" dirty="0">
+            <a:endParaRPr lang="en-US" sz="950" dirty="0"/>
+          </a:p>
+          <a:p>
+            <a:pPr indent="0" marL="0">
+              <a:spcAft>
+                <a:spcPts val="200"/>
+              </a:spcAft>
+              <a:buNone/>
+            </a:pPr>
+            <a:r>
+              <a:rPr lang="en-US" sz="950" b="1" dirty="0">
                 <a:solidFill>
                   <a:srgbClr val="123B3B"/>
                 </a:solidFill>
@@ -2901,21 +3278,21 @@
             </a:r>
             <a:pPr indent="0" marL="0">
               <a:spcAft>
-                <a:spcPts val="400"/>
-              </a:spcAft>
-              <a:buNone/>
-            </a:pPr>
-            <a:endParaRPr lang="en-US" sz="1100" dirty="0"/>
-          </a:p>
-          <a:p>
-            <a:pPr indent="0" marL="0">
-              <a:spcAft>
-                <a:spcPts val="400"/>
-              </a:spcAft>
-              <a:buNone/>
-            </a:pPr>
-            <a:r>
-              <a:rPr lang="en-US" sz="1100" dirty="0">
+                <a:spcPts val="200"/>
+              </a:spcAft>
+              <a:buNone/>
+            </a:pPr>
+            <a:endParaRPr lang="en-US" sz="950" dirty="0"/>
+          </a:p>
+          <a:p>
+            <a:pPr indent="0" marL="0">
+              <a:spcAft>
+                <a:spcPts val="200"/>
+              </a:spcAft>
+              <a:buNone/>
+            </a:pPr>
+            <a:r>
+              <a:rPr lang="en-US" sz="950" dirty="0">
                 <a:solidFill>
                   <a:srgbClr val="222222"/>
                 </a:solidFill>
@@ -2925,20 +3302,20 @@
               </a:rPr>
               <a:t>KPI 가설 포함 통합본</a:t>
             </a:r>
-            <a:endParaRPr lang="en-US" sz="1100" dirty="0"/>
-          </a:p>
-        </p:txBody>
-      </p:sp>
-      <p:sp>
-        <p:nvSpPr>
-          <p:cNvPr id="55" name="Card06Body"/>
+            <a:endParaRPr lang="en-US" sz="950" dirty="0"/>
+          </a:p>
+        </p:txBody>
+      </p:sp>
+      <p:sp>
+        <p:nvSpPr>
+          <p:cNvPr id="54" name="Card06Body"/>
           <p:cNvSpPr txBox="1"/>
           <p:nvPr/>
         </p:nvSpPr>
         <p:spPr>
           <a:xfrm>
-            <a:off x="7479792" y="3995928"/>
-            <a:ext cx="4087368" cy="2313432"/>
+            <a:off x="6839712" y="4471416"/>
+            <a:ext cx="4754880" cy="1920240"/>
           </a:xfrm>
           <a:prstGeom prst="rect">
             <a:avLst/>
@@ -2952,12 +3329,12 @@
           <a:p>
             <a:pPr indent="0" marL="0">
               <a:spcAft>
-                <a:spcPts val="200"/>
-              </a:spcAft>
-              <a:buNone/>
-            </a:pPr>
-            <a:r>
-              <a:rPr lang="en-US" sz="1050" b="1" dirty="0">
+                <a:spcPts val="100"/>
+              </a:spcAft>
+              <a:buNone/>
+            </a:pPr>
+            <a:r>
+              <a:rPr lang="en-US" sz="950" b="1" dirty="0">
                 <a:solidFill>
                   <a:srgbClr val="1B8A7A"/>
                 </a:solidFill>
@@ -2969,12 +3346,12 @@
             </a:r>
             <a:pPr indent="0" marL="0">
               <a:spcAft>
-                <a:spcPts val="200"/>
-              </a:spcAft>
-              <a:buNone/>
-            </a:pPr>
-            <a:r>
-              <a:rPr lang="en-US" sz="1050" b="1" dirty="0">
+                <a:spcPts val="100"/>
+              </a:spcAft>
+              <a:buNone/>
+            </a:pPr>
+            <a:r>
+              <a:rPr lang="en-US" sz="950" b="1" dirty="0">
                 <a:solidFill>
                   <a:srgbClr val="222222"/>
                 </a:solidFill>
@@ -2984,17 +3361,17 @@
               </a:rPr>
               <a:t>강보경, 김수연, 최유미, 문세련, 신다정</a:t>
             </a:r>
-            <a:endParaRPr lang="en-US" sz="1050" dirty="0"/>
-          </a:p>
-          <a:p>
-            <a:pPr indent="0" marL="0">
-              <a:spcAft>
-                <a:spcPts val="200"/>
-              </a:spcAft>
-              <a:buNone/>
-            </a:pPr>
-            <a:r>
-              <a:rPr lang="en-US" sz="1050" b="1" dirty="0">
+            <a:endParaRPr lang="en-US" sz="950" dirty="0"/>
+          </a:p>
+          <a:p>
+            <a:pPr indent="0" marL="0">
+              <a:spcAft>
+                <a:spcPts val="100"/>
+              </a:spcAft>
+              <a:buNone/>
+            </a:pPr>
+            <a:r>
+              <a:rPr lang="en-US" sz="950" b="1" dirty="0">
                 <a:solidFill>
                   <a:srgbClr val="1B8A7A"/>
                 </a:solidFill>
@@ -3006,21 +3383,21 @@
             </a:r>
             <a:pPr indent="0" marL="0">
               <a:spcAft>
-                <a:spcPts val="200"/>
-              </a:spcAft>
-              <a:buNone/>
-            </a:pPr>
-            <a:endParaRPr lang="en-US" sz="1050" dirty="0"/>
-          </a:p>
-          <a:p>
-            <a:pPr indent="0" marL="0">
-              <a:spcAft>
-                <a:spcPts val="200"/>
-              </a:spcAft>
-              <a:buNone/>
-            </a:pPr>
-            <a:r>
-              <a:rPr lang="en-US" sz="1050" b="1" dirty="0">
+                <a:spcPts val="100"/>
+              </a:spcAft>
+              <a:buNone/>
+            </a:pPr>
+            <a:endParaRPr lang="en-US" sz="950" dirty="0"/>
+          </a:p>
+          <a:p>
+            <a:pPr indent="0" marL="0">
+              <a:spcAft>
+                <a:spcPts val="100"/>
+              </a:spcAft>
+              <a:buNone/>
+            </a:pPr>
+            <a:r>
+              <a:rPr lang="en-US" sz="950" b="1" dirty="0">
                 <a:solidFill>
                   <a:srgbClr val="123B3B"/>
                 </a:solidFill>
@@ -3032,12 +3409,12 @@
             </a:r>
             <a:pPr indent="0" marL="0">
               <a:spcAft>
-                <a:spcPts val="200"/>
-              </a:spcAft>
-              <a:buNone/>
-            </a:pPr>
-            <a:r>
-              <a:rPr lang="en-US" sz="1050" dirty="0">
+                <a:spcPts val="100"/>
+              </a:spcAft>
+              <a:buNone/>
+            </a:pPr>
+            <a:r>
+              <a:rPr lang="en-US" sz="950" dirty="0">
                 <a:solidFill>
                   <a:srgbClr val="222222"/>
                 </a:solidFill>
@@ -3047,17 +3424,17 @@
               </a:rPr>
               <a:t>입점 채널 발굴 / 마케팅 이벤트 제안</a:t>
             </a:r>
-            <a:endParaRPr lang="en-US" sz="1050" dirty="0"/>
-          </a:p>
-          <a:p>
-            <a:pPr indent="0" marL="0">
-              <a:spcAft>
-                <a:spcPts val="200"/>
-              </a:spcAft>
-              <a:buNone/>
-            </a:pPr>
-            <a:r>
-              <a:rPr lang="en-US" sz="1050" b="1" dirty="0">
+            <a:endParaRPr lang="en-US" sz="950" dirty="0"/>
+          </a:p>
+          <a:p>
+            <a:pPr indent="0" marL="0">
+              <a:spcAft>
+                <a:spcPts val="100"/>
+              </a:spcAft>
+              <a:buNone/>
+            </a:pPr>
+            <a:r>
+              <a:rPr lang="en-US" sz="950" b="1" dirty="0">
                 <a:solidFill>
                   <a:srgbClr val="123B3B"/>
                 </a:solidFill>
@@ -3069,12 +3446,12 @@
             </a:r>
             <a:pPr indent="0" marL="0">
               <a:spcAft>
-                <a:spcPts val="200"/>
-              </a:spcAft>
-              <a:buNone/>
-            </a:pPr>
-            <a:r>
-              <a:rPr lang="en-US" sz="1050" dirty="0">
+                <a:spcPts val="100"/>
+              </a:spcAft>
+              <a:buNone/>
+            </a:pPr>
+            <a:r>
+              <a:rPr lang="en-US" sz="950" dirty="0">
                 <a:solidFill>
                   <a:srgbClr val="222222"/>
                 </a:solidFill>
@@ -3084,17 +3461,17 @@
               </a:rPr>
               <a:t>온라인채널 중심 커뮤니티 고객인지도 서치</a:t>
             </a:r>
-            <a:endParaRPr lang="en-US" sz="1050" dirty="0"/>
-          </a:p>
-          <a:p>
-            <a:pPr indent="0" marL="0">
-              <a:spcAft>
-                <a:spcPts val="200"/>
-              </a:spcAft>
-              <a:buNone/>
-            </a:pPr>
-            <a:r>
-              <a:rPr lang="en-US" sz="1050" b="1" dirty="0">
+            <a:endParaRPr lang="en-US" sz="950" dirty="0"/>
+          </a:p>
+          <a:p>
+            <a:pPr indent="0" marL="0">
+              <a:spcAft>
+                <a:spcPts val="100"/>
+              </a:spcAft>
+              <a:buNone/>
+            </a:pPr>
+            <a:r>
+              <a:rPr lang="en-US" sz="950" b="1" dirty="0">
                 <a:solidFill>
                   <a:srgbClr val="123B3B"/>
                 </a:solidFill>
@@ -3106,12 +3483,12 @@
             </a:r>
             <a:pPr indent="0" marL="0">
               <a:spcAft>
-                <a:spcPts val="200"/>
-              </a:spcAft>
-              <a:buNone/>
-            </a:pPr>
-            <a:r>
-              <a:rPr lang="en-US" sz="1050" dirty="0">
+                <a:spcPts val="100"/>
+              </a:spcAft>
+              <a:buNone/>
+            </a:pPr>
+            <a:r>
+              <a:rPr lang="en-US" sz="950" dirty="0">
                 <a:solidFill>
                   <a:srgbClr val="222222"/>
                 </a:solidFill>
@@ -3121,17 +3498,17 @@
               </a:rPr>
               <a:t>온라인 마케팅 (B2C 컨텐츠 플랜과 SNS 시안) 제안</a:t>
             </a:r>
-            <a:endParaRPr lang="en-US" sz="1050" dirty="0"/>
-          </a:p>
-          <a:p>
-            <a:pPr indent="0" marL="0">
-              <a:spcAft>
-                <a:spcPts val="200"/>
-              </a:spcAft>
-              <a:buNone/>
-            </a:pPr>
-            <a:r>
-              <a:rPr lang="en-US" sz="1050" b="1" dirty="0">
+            <a:endParaRPr lang="en-US" sz="950" dirty="0"/>
+          </a:p>
+          <a:p>
+            <a:pPr indent="0" marL="0">
+              <a:spcAft>
+                <a:spcPts val="100"/>
+              </a:spcAft>
+              <a:buNone/>
+            </a:pPr>
+            <a:r>
+              <a:rPr lang="en-US" sz="950" b="1" dirty="0">
                 <a:solidFill>
                   <a:srgbClr val="123B3B"/>
                 </a:solidFill>
@@ -3143,12 +3520,12 @@
             </a:r>
             <a:pPr indent="0" marL="0">
               <a:spcAft>
-                <a:spcPts val="200"/>
-              </a:spcAft>
-              <a:buNone/>
-            </a:pPr>
-            <a:r>
-              <a:rPr lang="en-US" sz="1050" dirty="0">
+                <a:spcPts val="100"/>
+              </a:spcAft>
+              <a:buNone/>
+            </a:pPr>
+            <a:r>
+              <a:rPr lang="en-US" sz="950" dirty="0">
                 <a:solidFill>
                   <a:srgbClr val="222222"/>
                 </a:solidFill>
@@ -3158,17 +3535,17 @@
               </a:rPr>
               <a:t>구매전환 콘텐츠 기획</a:t>
             </a:r>
-            <a:endParaRPr lang="en-US" sz="1050" dirty="0"/>
-          </a:p>
-          <a:p>
-            <a:pPr indent="0" marL="0">
-              <a:spcAft>
-                <a:spcPts val="200"/>
-              </a:spcAft>
-              <a:buNone/>
-            </a:pPr>
-            <a:r>
-              <a:rPr lang="en-US" sz="1050" b="1" dirty="0">
+            <a:endParaRPr lang="en-US" sz="950" dirty="0"/>
+          </a:p>
+          <a:p>
+            <a:pPr indent="0" marL="0">
+              <a:spcAft>
+                <a:spcPts val="100"/>
+              </a:spcAft>
+              <a:buNone/>
+            </a:pPr>
+            <a:r>
+              <a:rPr lang="en-US" sz="950" b="1" dirty="0">
                 <a:solidFill>
                   <a:srgbClr val="123B3B"/>
                 </a:solidFill>
@@ -3180,12 +3557,12 @@
             </a:r>
             <a:pPr indent="0" marL="0">
               <a:spcAft>
-                <a:spcPts val="200"/>
-              </a:spcAft>
-              <a:buNone/>
-            </a:pPr>
-            <a:r>
-              <a:rPr lang="en-US" sz="1050" dirty="0">
+                <a:spcPts val="100"/>
+              </a:spcAft>
+              <a:buNone/>
+            </a:pPr>
+            <a:r>
+              <a:rPr lang="en-US" sz="950" dirty="0">
                 <a:solidFill>
                   <a:srgbClr val="222222"/>
                 </a:solidFill>
@@ -3195,17 +3572,17 @@
               </a:rPr>
               <a:t>라파앤코 사이트 분석, 경쟁사 조사 &gt; 고객 피드백 확인, B2B·B2C 제휴 채널 리서치</a:t>
             </a:r>
-            <a:endParaRPr lang="en-US" sz="1050" dirty="0"/>
-          </a:p>
-          <a:p>
-            <a:pPr indent="0" marL="0">
-              <a:spcAft>
-                <a:spcPts val="200"/>
-              </a:spcAft>
-              <a:buNone/>
-            </a:pPr>
-            <a:r>
-              <a:rPr lang="en-US" sz="1050" b="1" dirty="0">
+            <a:endParaRPr lang="en-US" sz="950" dirty="0"/>
+          </a:p>
+          <a:p>
+            <a:pPr indent="0" marL="0">
+              <a:spcAft>
+                <a:spcPts val="100"/>
+              </a:spcAft>
+              <a:buNone/>
+            </a:pPr>
+            <a:r>
+              <a:rPr lang="en-US" sz="950" b="1" dirty="0">
                 <a:solidFill>
                   <a:srgbClr val="1B8A7A"/>
                 </a:solidFill>
@@ -3217,12 +3594,12 @@
             </a:r>
             <a:pPr indent="0" marL="0">
               <a:spcAft>
-                <a:spcPts val="200"/>
-              </a:spcAft>
-              <a:buNone/>
-            </a:pPr>
-            <a:r>
-              <a:rPr lang="en-US" sz="1050" dirty="0">
+                <a:spcPts val="100"/>
+              </a:spcAft>
+              <a:buNone/>
+            </a:pPr>
+            <a:r>
+              <a:rPr lang="en-US" sz="950" dirty="0">
                 <a:solidFill>
                   <a:srgbClr val="222222"/>
                 </a:solidFill>
@@ -3232,17 +3609,17 @@
               </a:rPr>
               <a:t>모두가 함께 아이디어를 제안하고 합의하여 결정 (의견 충돌 시 다수결)</a:t>
             </a:r>
-            <a:endParaRPr lang="en-US" sz="1050" dirty="0"/>
-          </a:p>
-          <a:p>
-            <a:pPr indent="0" marL="0">
-              <a:spcAft>
-                <a:spcPts val="200"/>
-              </a:spcAft>
-              <a:buNone/>
-            </a:pPr>
-            <a:r>
-              <a:rPr lang="en-US" sz="1050" b="1" dirty="0">
+            <a:endParaRPr lang="en-US" sz="950" dirty="0"/>
+          </a:p>
+          <a:p>
+            <a:pPr indent="0" marL="0">
+              <a:spcAft>
+                <a:spcPts val="100"/>
+              </a:spcAft>
+              <a:buNone/>
+            </a:pPr>
+            <a:r>
+              <a:rPr lang="en-US" sz="950" b="1" dirty="0">
                 <a:solidFill>
                   <a:srgbClr val="1B8A7A"/>
                 </a:solidFill>
@@ -3254,12 +3631,12 @@
             </a:r>
             <a:pPr indent="0" marL="0">
               <a:spcAft>
-                <a:spcPts val="200"/>
-              </a:spcAft>
-              <a:buNone/>
-            </a:pPr>
-            <a:r>
-              <a:rPr lang="en-US" sz="1050" dirty="0">
+                <a:spcPts val="100"/>
+              </a:spcAft>
+              <a:buNone/>
+            </a:pPr>
+            <a:r>
+              <a:rPr lang="en-US" sz="950" dirty="0">
                 <a:solidFill>
                   <a:srgbClr val="222222"/>
                 </a:solidFill>
@@ -3269,17 +3646,17 @@
               </a:rPr>
               <a:t>서로 의견을 존중하고 함께 작업하여 최대한 업무 부담을 줄이는 쪽으로 프로젝트 진행 예정</a:t>
             </a:r>
-            <a:endParaRPr lang="en-US" sz="1050" dirty="0"/>
-          </a:p>
-          <a:p>
-            <a:pPr indent="0" marL="0">
-              <a:spcAft>
-                <a:spcPts val="200"/>
-              </a:spcAft>
-              <a:buNone/>
-            </a:pPr>
-            <a:r>
-              <a:rPr lang="en-US" sz="1050" b="1" dirty="0">
+            <a:endParaRPr lang="en-US" sz="950" dirty="0"/>
+          </a:p>
+          <a:p>
+            <a:pPr indent="0" marL="0">
+              <a:spcAft>
+                <a:spcPts val="100"/>
+              </a:spcAft>
+              <a:buNone/>
+            </a:pPr>
+            <a:r>
+              <a:rPr lang="en-US" sz="950" b="1" dirty="0">
                 <a:solidFill>
                   <a:srgbClr val="1B8A7A"/>
                 </a:solidFill>
@@ -3291,12 +3668,12 @@
             </a:r>
             <a:pPr indent="0" marL="0">
               <a:spcAft>
-                <a:spcPts val="200"/>
-              </a:spcAft>
-              <a:buNone/>
-            </a:pPr>
-            <a:r>
-              <a:rPr lang="en-US" sz="1050" dirty="0">
+                <a:spcPts val="100"/>
+              </a:spcAft>
+              <a:buNone/>
+            </a:pPr>
+            <a:r>
+              <a:rPr lang="en-US" sz="950" dirty="0">
                 <a:solidFill>
                   <a:srgbClr val="222222"/>
                 </a:solidFill>
@@ -3306,13 +3683,13 @@
               </a:rPr>
               <a:t>카카오톡, Google Doc</a:t>
             </a:r>
-            <a:endParaRPr lang="en-US" sz="1050" dirty="0"/>
-          </a:p>
-        </p:txBody>
-      </p:sp>
-      <p:sp>
-        <p:nvSpPr>
-          <p:cNvPr id="56" name="Shape 54"/>
+            <a:endParaRPr lang="en-US" sz="950" dirty="0"/>
+          </a:p>
+        </p:txBody>
+      </p:sp>
+      <p:sp>
+        <p:nvSpPr>
+          <p:cNvPr id="55" name="Shape 53"/>
           <p:cNvSpPr/>
           <p:nvPr/>
         </p:nvSpPr>
@@ -3335,14 +3712,53 @@
       </p:sp>
       <p:sp>
         <p:nvSpPr>
+          <p:cNvPr id="56" name="Text 54"/>
+          <p:cNvSpPr txBox="1"/>
+          <p:nvPr/>
+        </p:nvSpPr>
+        <p:spPr>
+          <a:xfrm>
+            <a:off x="457200" y="6537960"/>
+            <a:ext cx="822960" cy="228600"/>
+          </a:xfrm>
+          <a:prstGeom prst="rect">
+            <a:avLst/>
+          </a:prstGeom>
+          <a:noFill/>
+          <a:ln/>
+        </p:spPr>
+        <p:txBody>
+          <a:bodyPr wrap="square" lIns="0" tIns="0" rIns="0" bIns="0" rtlCol="0" anchor="t"/>
+          <a:lstStyle/>
+          <a:p>
+            <a:pPr indent="0" marL="0">
+              <a:buNone/>
+            </a:pPr>
+            <a:r>
+              <a:rPr lang="en-US" sz="900" b="1" dirty="0">
+                <a:solidFill>
+                  <a:srgbClr val="1B8A7A"/>
+                </a:solidFill>
+                <a:latin typeface="Malgun Gothic" pitchFamily="34" charset="0"/>
+                <a:ea typeface="Malgun Gothic" pitchFamily="34" charset="-122"/>
+                <a:cs typeface="Malgun Gothic" pitchFamily="34" charset="-120"/>
+              </a:rPr>
+              <a:t>작성 TIP</a:t>
+            </a:r>
+            <a:endParaRPr lang="en-US" sz="900" dirty="0"/>
+          </a:p>
+        </p:txBody>
+      </p:sp>
+      <p:sp>
+        <p:nvSpPr>
           <p:cNvPr id="57" name="Text 55"/>
           <p:cNvSpPr txBox="1"/>
           <p:nvPr/>
         </p:nvSpPr>
         <p:spPr>
           <a:xfrm>
-            <a:off x="457200" y="6537960"/>
-            <a:ext cx="822960" cy="228600"/>
+            <a:off x="1280160" y="6537960"/>
+            <a:ext cx="9601200" cy="228600"/>
           </a:xfrm>
           <a:prstGeom prst="rect">
             <a:avLst/>
@@ -3358,7 +3774,7 @@
               <a:buNone/>
             </a:pPr>
             <a:r>
-              <a:rPr lang="en-US" sz="950" b="1" dirty="0">
+              <a:rPr lang="en-US" sz="900" dirty="0">
                 <a:solidFill>
                   <a:srgbClr val="1B8A7A"/>
                 </a:solidFill>
@@ -3366,9 +3782,9 @@
                 <a:ea typeface="Malgun Gothic" pitchFamily="34" charset="-122"/>
                 <a:cs typeface="Malgun Gothic" pitchFamily="34" charset="-120"/>
               </a:rPr>
-              <a:t>작성 TIP</a:t>
-            </a:r>
-            <a:endParaRPr lang="en-US" sz="950" dirty="0"/>
+              <a:t>각 항목 2~4줄이면 충분합니다. 지금은 "정답"보다 현재 팀의 합의와 가설을 명확히 남기는 것이 목적입니다.</a:t>
+            </a:r>
+            <a:endParaRPr lang="en-US" sz="900" dirty="0"/>
           </a:p>
         </p:txBody>
       </p:sp>
@@ -3380,45 +3796,6 @@
         </p:nvSpPr>
         <p:spPr>
           <a:xfrm>
-            <a:off x="1280160" y="6537960"/>
-            <a:ext cx="9601200" cy="228600"/>
-          </a:xfrm>
-          <a:prstGeom prst="rect">
-            <a:avLst/>
-          </a:prstGeom>
-          <a:noFill/>
-          <a:ln/>
-        </p:spPr>
-        <p:txBody>
-          <a:bodyPr wrap="square" lIns="0" tIns="0" rIns="0" bIns="0" rtlCol="0" anchor="t"/>
-          <a:lstStyle/>
-          <a:p>
-            <a:pPr indent="0" marL="0">
-              <a:buNone/>
-            </a:pPr>
-            <a:r>
-              <a:rPr lang="en-US" sz="950" dirty="0">
-                <a:solidFill>
-                  <a:srgbClr val="1B8A7A"/>
-                </a:solidFill>
-                <a:latin typeface="Malgun Gothic" pitchFamily="34" charset="0"/>
-                <a:ea typeface="Malgun Gothic" pitchFamily="34" charset="-122"/>
-                <a:cs typeface="Malgun Gothic" pitchFamily="34" charset="-120"/>
-              </a:rPr>
-              <a:t>각 항목 2~4줄이면 충분합니다. 지금은 "정답"보다 현재 팀의 합의와 가설을 명확히 남기는 것이 목적입니다.</a:t>
-            </a:r>
-            <a:endParaRPr lang="en-US" sz="950" dirty="0"/>
-          </a:p>
-        </p:txBody>
-      </p:sp>
-      <p:sp>
-        <p:nvSpPr>
-          <p:cNvPr id="59" name="Text 57"/>
-          <p:cNvSpPr txBox="1"/>
-          <p:nvPr/>
-        </p:nvSpPr>
-        <p:spPr>
-          <a:xfrm>
             <a:off x="11155680" y="6537960"/>
             <a:ext cx="576072" cy="228600"/>
           </a:xfrm>
@@ -3436,7 +3813,7 @@
               <a:buNone/>
             </a:pPr>
             <a:r>
-              <a:rPr lang="en-US" sz="950" dirty="0">
+              <a:rPr lang="en-US" sz="900" dirty="0">
                 <a:solidFill>
                   <a:srgbClr val="6B6B6B"/>
                 </a:solidFill>
@@ -3446,7 +3823,7 @@
               </a:rPr>
               <a:t>01</a:t>
             </a:r>
-            <a:endParaRPr lang="en-US" sz="950" dirty="0"/>
+            <a:endParaRPr lang="en-US" sz="900" dirty="0"/>
           </a:p>
         </p:txBody>
       </p:sp>

</xml_diff>